<commit_message>
minor ppt fix and report fix
</commit_message>
<xml_diff>
--- a/FELCOM_Presentation.pptx
+++ b/FELCOM_Presentation.pptx
@@ -4,6 +4,9 @@
   <p:sldMasterIdLst>
     <p:sldMasterId id="2147483648" r:id="rId1"/>
   </p:sldMasterIdLst>
+  <p:notesMasterIdLst>
+    <p:notesMasterId r:id="rId17"/>
+  </p:notesMasterIdLst>
   <p:sldIdLst>
     <p:sldId id="256" r:id="rId2"/>
     <p:sldId id="257" r:id="rId3"/>
@@ -21,11 +24,8 @@
     <p:sldId id="269" r:id="rId15"/>
     <p:sldId id="270" r:id="rId16"/>
   </p:sldIdLst>
-  <p:notesMasterIdLst>
-    <p:notesMasterId r:id="rId17"/>
-  </p:notesMasterIdLst>
-  <p:sldSz cx="12191695" cy="6858000"/>
-  <p:notesSz cx="6858000" cy="12191695"/>
+  <p:sldSz cx="12192000" cy="6858000"/>
+  <p:notesSz cx="6858000" cy="12192000"/>
   <p:defaultTextStyle>
     <a:lvl1pPr marL="0" algn="l" defTabSz="914400" rtl="0" eaLnBrk="1" latinLnBrk="0" hangingPunct="1">
       <a:defRPr sz="1800" kern="1200">
@@ -118,6 +118,11 @@
       </a:defRPr>
     </a:lvl9pPr>
   </p:defaultTextStyle>
+  <p:extLst>
+    <p:ext uri="{EFAFB233-063F-42B5-8137-9DF3F51BA10A}">
+      <p15:sldGuideLst xmlns:p15="http://schemas.microsoft.com/office/powerpoint/2012/main"/>
+    </p:ext>
+  </p:extLst>
 </p:presentation>
 </file>
 
@@ -143,234 +148,10 @@
           <a:chExt cx="0" cy="0"/>
         </a:xfrm>
       </p:grpSpPr>
-      <p:sp>
-        <p:nvSpPr>
-          <p:cNvPr id="2" name="Header Placeholder 1"/>
-          <p:cNvSpPr>
-            <a:spLocks noGrp="1"/>
-          </p:cNvSpPr>
-          <p:nvPr>
-            <p:ph type="hdr" sz="quarter"/>
-          </p:nvPr>
-        </p:nvSpPr>
-        <p:spPr>
-          <a:xfrm>
-            <a:off x="0" y="0"/>
-            <a:ext cx="2971800" cy="458788"/>
-          </a:xfrm>
-          <a:prstGeom prst="rect">
-            <a:avLst/>
-          </a:prstGeom>
-        </p:spPr>
-        <p:txBody>
-          <a:bodyPr vert="horz" lIns="91440" tIns="45720" rIns="91440" bIns="45720" rtlCol="0"/>
-          <a:lstStyle>
-            <a:lvl1pPr algn="l">
-              <a:defRPr sz="1200"/>
-            </a:lvl1pPr>
-          </a:lstStyle>
-          <a:p>
-            <a:endParaRPr lang="en-US"/>
-          </a:p>
-        </p:txBody>
-      </p:sp>
-      <p:sp>
-        <p:nvSpPr>
-          <p:cNvPr id="3" name="Date Placeholder 2"/>
-          <p:cNvSpPr>
-            <a:spLocks noGrp="1"/>
-          </p:cNvSpPr>
-          <p:nvPr>
-            <p:ph type="dt" idx="1"/>
-          </p:nvPr>
-        </p:nvSpPr>
-        <p:spPr>
-          <a:xfrm>
-            <a:off x="3884613" y="0"/>
-            <a:ext cx="2971800" cy="458788"/>
-          </a:xfrm>
-          <a:prstGeom prst="rect">
-            <a:avLst/>
-          </a:prstGeom>
-        </p:spPr>
-        <p:txBody>
-          <a:bodyPr vert="horz" lIns="91440" tIns="45720" rIns="91440" bIns="45720" rtlCol="0"/>
-          <a:lstStyle>
-            <a:lvl1pPr algn="r">
-              <a:defRPr sz="1200"/>
-            </a:lvl1pPr>
-          </a:lstStyle>
-          <a:p>
-            <a:fld id="{5282F153-3F37-0F45-9E97-73ACFA13230C}" type="datetimeFigureOut">
-              <a:rPr lang="en-US"/>
-              <a:t>7/23/19</a:t>
-            </a:fld>
-            <a:endParaRPr lang="en-US"/>
-          </a:p>
-        </p:txBody>
-      </p:sp>
-      <p:sp>
-        <p:nvSpPr>
-          <p:cNvPr id="4" name="Slide Image Placeholder 3"/>
-          <p:cNvSpPr>
-            <a:spLocks noGrp="1" noRot="1" noChangeAspect="1"/>
-          </p:cNvSpPr>
-          <p:nvPr>
-            <p:ph type="sldImg" idx="2"/>
-          </p:nvPr>
-        </p:nvSpPr>
-        <p:spPr>
-          <a:xfrm>
-            <a:off x="685800" y="1143000"/>
-            <a:ext cx="5486400" cy="3086100"/>
-          </a:xfrm>
-          <a:prstGeom prst="rect">
-            <a:avLst/>
-          </a:prstGeom>
-          <a:noFill/>
-          <a:ln w="12700">
-            <a:solidFill>
-              <a:prstClr val="black"/>
-            </a:solidFill>
-          </a:ln>
-        </p:spPr>
-        <p:txBody>
-          <a:bodyPr vert="horz" lIns="91440" tIns="45720" rIns="91440" bIns="45720" rtlCol="0" anchor="ctr"/>
-          <a:lstStyle/>
-          <a:p>
-            <a:endParaRPr lang="en-US"/>
-          </a:p>
-        </p:txBody>
-      </p:sp>
-      <p:sp>
-        <p:nvSpPr>
-          <p:cNvPr id="5" name="Notes Placeholder 4"/>
-          <p:cNvSpPr>
-            <a:spLocks noGrp="1"/>
-          </p:cNvSpPr>
-          <p:nvPr>
-            <p:ph type="body" sz="quarter" idx="3"/>
-          </p:nvPr>
-        </p:nvSpPr>
-        <p:spPr>
-          <a:xfrm>
-            <a:off x="685800" y="4400550"/>
-            <a:ext cx="5486400" cy="3600450"/>
-          </a:xfrm>
-          <a:prstGeom prst="rect">
-            <a:avLst/>
-          </a:prstGeom>
-        </p:spPr>
-        <p:txBody>
-          <a:bodyPr vert="horz" lIns="91440" tIns="45720" rIns="91440" bIns="45720" rtlCol="0"/>
-          <a:lstStyle/>
-          <a:p>
-            <a:pPr lvl="0"/>
-            <a:r>
-              <a:rPr lang="en-US"/>
-              <a:t>Click to edit Master text styles</a:t>
-            </a:r>
-          </a:p>
-          <a:p>
-            <a:pPr lvl="1"/>
-            <a:r>
-              <a:rPr lang="en-US"/>
-              <a:t>Second level</a:t>
-            </a:r>
-          </a:p>
-          <a:p>
-            <a:pPr lvl="2"/>
-            <a:r>
-              <a:rPr lang="en-US"/>
-              <a:t>Third level</a:t>
-            </a:r>
-          </a:p>
-          <a:p>
-            <a:pPr lvl="3"/>
-            <a:r>
-              <a:rPr lang="en-US"/>
-              <a:t>Fourth level</a:t>
-            </a:r>
-          </a:p>
-          <a:p>
-            <a:pPr lvl="4"/>
-            <a:r>
-              <a:rPr lang="en-US"/>
-              <a:t>Fifth level</a:t>
-            </a:r>
-          </a:p>
-        </p:txBody>
-      </p:sp>
-      <p:sp>
-        <p:nvSpPr>
-          <p:cNvPr id="6" name="Footer Placeholder 5"/>
-          <p:cNvSpPr>
-            <a:spLocks noGrp="1"/>
-          </p:cNvSpPr>
-          <p:nvPr>
-            <p:ph type="ftr" sz="quarter" idx="4"/>
-          </p:nvPr>
-        </p:nvSpPr>
-        <p:spPr>
-          <a:xfrm>
-            <a:off x="0" y="8685213"/>
-            <a:ext cx="2971800" cy="458787"/>
-          </a:xfrm>
-          <a:prstGeom prst="rect">
-            <a:avLst/>
-          </a:prstGeom>
-        </p:spPr>
-        <p:txBody>
-          <a:bodyPr vert="horz" lIns="91440" tIns="45720" rIns="91440" bIns="45720" rtlCol="0" anchor="b"/>
-          <a:lstStyle>
-            <a:lvl1pPr algn="l">
-              <a:defRPr sz="1200"/>
-            </a:lvl1pPr>
-          </a:lstStyle>
-          <a:p>
-            <a:endParaRPr lang="en-US"/>
-          </a:p>
-        </p:txBody>
-      </p:sp>
-      <p:sp>
-        <p:nvSpPr>
-          <p:cNvPr id="7" name="Slide Number Placeholder 6"/>
-          <p:cNvSpPr>
-            <a:spLocks noGrp="1"/>
-          </p:cNvSpPr>
-          <p:nvPr>
-            <p:ph type="sldNum" sz="quarter" idx="5"/>
-          </p:nvPr>
-        </p:nvSpPr>
-        <p:spPr>
-          <a:xfrm>
-            <a:off x="3884613" y="8685213"/>
-            <a:ext cx="2971800" cy="458787"/>
-          </a:xfrm>
-          <a:prstGeom prst="rect">
-            <a:avLst/>
-          </a:prstGeom>
-        </p:spPr>
-        <p:txBody>
-          <a:bodyPr vert="horz" lIns="91440" tIns="45720" rIns="91440" bIns="45720" rtlCol="0" anchor="b"/>
-          <a:lstStyle>
-            <a:lvl1pPr algn="r">
-              <a:defRPr sz="1200"/>
-            </a:lvl1pPr>
-          </a:lstStyle>
-          <a:p>
-            <a:fld id="{CE5E9CC1-C706-0F49-92D6-E571CC5EEA8F}" type="slidenum">
-              <a:rPr lang="en-US"/>
-              <a:t>‹#›</a:t>
-            </a:fld>
-            <a:endParaRPr lang="en-US"/>
-          </a:p>
-        </p:txBody>
-      </p:sp>
     </p:spTree>
     <p:extLst>
       <p:ext uri="{BB962C8B-B14F-4D97-AF65-F5344CB8AC3E}">
-        <p14:creationId xmlns:p14="http://schemas.microsoft.com/office/powerpoint/2010/main" val="1024086991"/>
+        <p14:creationId xmlns:p14="http://schemas.microsoft.com/office/powerpoint/2010/main" val="1936333488"/>
       </p:ext>
     </p:extLst>
   </p:cSld>
@@ -514,10 +295,6 @@
           <a:bodyPr/>
           <a:lstStyle/>
           <a:p>
-            <a:r>
-              <a:rPr lang="en-US" dirty="0"/>
-              <a:t/>
-            </a:r>
             <a:endParaRPr lang="en-US" dirty="0"/>
           </a:p>
         </p:txBody>
@@ -602,10 +379,6 @@
           <a:bodyPr/>
           <a:lstStyle/>
           <a:p>
-            <a:r>
-              <a:rPr lang="en-US" dirty="0"/>
-              <a:t/>
-            </a:r>
             <a:endParaRPr lang="en-US" dirty="0"/>
           </a:p>
         </p:txBody>
@@ -690,10 +463,6 @@
           <a:bodyPr/>
           <a:lstStyle/>
           <a:p>
-            <a:r>
-              <a:rPr lang="en-US" dirty="0"/>
-              <a:t/>
-            </a:r>
             <a:endParaRPr lang="en-US" dirty="0"/>
           </a:p>
         </p:txBody>
@@ -778,10 +547,6 @@
           <a:bodyPr/>
           <a:lstStyle/>
           <a:p>
-            <a:r>
-              <a:rPr lang="en-US" dirty="0"/>
-              <a:t/>
-            </a:r>
             <a:endParaRPr lang="en-US" dirty="0"/>
           </a:p>
         </p:txBody>
@@ -866,10 +631,6 @@
           <a:bodyPr/>
           <a:lstStyle/>
           <a:p>
-            <a:r>
-              <a:rPr lang="en-US" dirty="0"/>
-              <a:t/>
-            </a:r>
             <a:endParaRPr lang="en-US" dirty="0"/>
           </a:p>
         </p:txBody>
@@ -954,10 +715,6 @@
           <a:bodyPr/>
           <a:lstStyle/>
           <a:p>
-            <a:r>
-              <a:rPr lang="en-US" dirty="0"/>
-              <a:t/>
-            </a:r>
             <a:endParaRPr lang="en-US" dirty="0"/>
           </a:p>
         </p:txBody>
@@ -1042,10 +799,6 @@
           <a:bodyPr/>
           <a:lstStyle/>
           <a:p>
-            <a:r>
-              <a:rPr lang="en-US" dirty="0"/>
-              <a:t/>
-            </a:r>
             <a:endParaRPr lang="en-US" dirty="0"/>
           </a:p>
         </p:txBody>
@@ -1130,10 +883,6 @@
           <a:bodyPr/>
           <a:lstStyle/>
           <a:p>
-            <a:r>
-              <a:rPr lang="en-US" dirty="0"/>
-              <a:t/>
-            </a:r>
             <a:endParaRPr lang="en-US" dirty="0"/>
           </a:p>
         </p:txBody>
@@ -1218,10 +967,6 @@
           <a:bodyPr/>
           <a:lstStyle/>
           <a:p>
-            <a:r>
-              <a:rPr lang="en-US" dirty="0"/>
-              <a:t/>
-            </a:r>
             <a:endParaRPr lang="en-US" dirty="0"/>
           </a:p>
         </p:txBody>
@@ -1306,10 +1051,6 @@
           <a:bodyPr/>
           <a:lstStyle/>
           <a:p>
-            <a:r>
-              <a:rPr lang="en-US" dirty="0"/>
-              <a:t/>
-            </a:r>
             <a:endParaRPr lang="en-US" dirty="0"/>
           </a:p>
         </p:txBody>
@@ -1394,10 +1135,6 @@
           <a:bodyPr/>
           <a:lstStyle/>
           <a:p>
-            <a:r>
-              <a:rPr lang="en-US" dirty="0"/>
-              <a:t/>
-            </a:r>
             <a:endParaRPr lang="en-US" dirty="0"/>
           </a:p>
         </p:txBody>
@@ -1482,10 +1219,6 @@
           <a:bodyPr/>
           <a:lstStyle/>
           <a:p>
-            <a:r>
-              <a:rPr lang="en-US" dirty="0"/>
-              <a:t/>
-            </a:r>
             <a:endParaRPr lang="en-US" dirty="0"/>
           </a:p>
         </p:txBody>
@@ -1570,10 +1303,6 @@
           <a:bodyPr/>
           <a:lstStyle/>
           <a:p>
-            <a:r>
-              <a:rPr lang="en-US" dirty="0"/>
-              <a:t/>
-            </a:r>
             <a:endParaRPr lang="en-US" dirty="0"/>
           </a:p>
         </p:txBody>
@@ -1658,10 +1387,6 @@
           <a:bodyPr/>
           <a:lstStyle/>
           <a:p>
-            <a:r>
-              <a:rPr lang="en-US" dirty="0"/>
-              <a:t/>
-            </a:r>
             <a:endParaRPr lang="en-US" dirty="0"/>
           </a:p>
         </p:txBody>
@@ -1746,10 +1471,6 @@
           <a:bodyPr/>
           <a:lstStyle/>
           <a:p>
-            <a:r>
-              <a:rPr lang="en-US" dirty="0"/>
-              <a:t/>
-            </a:r>
             <a:endParaRPr lang="en-US" dirty="0"/>
           </a:p>
         </p:txBody>
@@ -1823,6 +1544,11 @@
 <file path=ppt/slideMasters/slideMaster1.xml><?xml version="1.0" encoding="utf-8"?>
 <p:sldMaster xmlns:a="http://schemas.openxmlformats.org/drawingml/2006/main" xmlns:r="http://schemas.openxmlformats.org/officeDocument/2006/relationships" xmlns:p="http://schemas.openxmlformats.org/presentationml/2006/main">
   <p:cSld>
+    <p:bg>
+      <p:bgRef idx="1001">
+        <a:schemeClr val="bg1"/>
+      </p:bgRef>
+    </p:bg>
     <p:spTree>
       <p:nvGrpSpPr>
         <p:cNvPr id="1" name=""/>
@@ -2105,6 +1831,7 @@
         <a:solidFill>
           <a:srgbClr val="1E1B3A"/>
         </a:solidFill>
+        <a:effectLst/>
       </p:bgPr>
     </p:bg>
     <p:spTree>
@@ -2246,7 +1973,7 @@
           <a:bodyPr wrap="square" rtlCol="0" anchor="ctr"/>
           <a:lstStyle/>
           <a:p>
-            <a:pPr indent="0" marL="0">
+            <a:pPr marL="0" indent="0">
               <a:buNone/>
             </a:pPr>
             <a:r>
@@ -2285,7 +2012,7 @@
           <a:bodyPr wrap="square" rtlCol="0" anchor="ctr"/>
           <a:lstStyle/>
           <a:p>
-            <a:pPr indent="0" marL="0">
+            <a:pPr marL="0" indent="0">
               <a:buNone/>
             </a:pPr>
             <a:r>
@@ -2364,7 +2091,7 @@
           <a:bodyPr wrap="square" rtlCol="0" anchor="t"/>
           <a:lstStyle/>
           <a:p>
-            <a:pPr indent="0" marL="0">
+            <a:pPr marL="0" indent="0">
               <a:spcAft>
                 <a:spcPts val="1400"/>
               </a:spcAft>
@@ -2384,7 +2111,7 @@
             <a:endParaRPr lang="en-US" sz="1900" dirty="0"/>
           </a:p>
           <a:p>
-            <a:pPr indent="0" marL="0">
+            <a:pPr marL="0" indent="0">
               <a:spcAft>
                 <a:spcPts val="700"/>
               </a:spcAft>
@@ -2404,7 +2131,7 @@
             <a:endParaRPr lang="en-US" sz="1900" dirty="0"/>
           </a:p>
           <a:p>
-            <a:pPr indent="0" marL="0">
+            <a:pPr marL="0" indent="0">
               <a:spcAft>
                 <a:spcPts val="700"/>
               </a:spcAft>
@@ -2424,7 +2151,7 @@
             <a:endParaRPr lang="en-US" sz="1900" dirty="0"/>
           </a:p>
           <a:p>
-            <a:pPr indent="0" marL="0">
+            <a:pPr marL="0" indent="0">
               <a:spcAft>
                 <a:spcPts val="1200"/>
               </a:spcAft>
@@ -2469,15 +2196,15 @@
       </p:sp>
       <p:pic>
         <p:nvPicPr>
-          <p:cNvPr id="13" name="Image 0" descr="C:/Users/h/Desktop/Mini-project Fec/Mini-Project/hardware/imgs/FELCOM assembled.jpeg">    </p:cNvPr>
+          <p:cNvPr id="13" name="Image 0" descr="C:/Users/h/Desktop/Mini-project Fec/Mini-Project/hardware/imgs/FELCOM assembled.jpeg"/>
           <p:cNvPicPr>
             <a:picLocks noChangeAspect="1"/>
           </p:cNvPicPr>
           <p:nvPr/>
         </p:nvPicPr>
         <p:blipFill>
-          <a:blip r:embed="rId1"/>
-          <a:srcRect l="0" r="0" t="0" b="0"/>
+          <a:blip r:embed="rId3"/>
+          <a:srcRect/>
           <a:stretch/>
         </p:blipFill>
         <p:spPr>
@@ -2506,6 +2233,7 @@
         <a:solidFill>
           <a:srgbClr val="FFFFFF"/>
         </a:solidFill>
+        <a:effectLst/>
       </p:bgPr>
     </p:bg>
     <p:spTree>
@@ -2603,7 +2331,7 @@
           <a:bodyPr wrap="square" rtlCol="0" anchor="ctr"/>
           <a:lstStyle/>
           <a:p>
-            <a:pPr indent="0" marL="0">
+            <a:pPr marL="0" indent="0">
               <a:buNone/>
             </a:pPr>
             <a:r>
@@ -2669,7 +2397,7 @@
           <a:bodyPr wrap="square" rtlCol="0" anchor="ctr"/>
           <a:lstStyle/>
           <a:p>
-            <a:pPr indent="0" marL="0">
+            <a:pPr marL="0" indent="0">
               <a:buNone/>
             </a:pPr>
             <a:r>
@@ -2820,7 +2548,7 @@
           <a:bodyPr wrap="square" rtlCol="0" anchor="ctr"/>
           <a:lstStyle/>
           <a:p>
-            <a:pPr indent="0" marL="0">
+            <a:pPr marL="0" indent="0">
               <a:buNone/>
             </a:pPr>
             <a:r>
@@ -3006,7 +2734,7 @@
           <a:bodyPr wrap="square" rtlCol="0" anchor="ctr"/>
           <a:lstStyle/>
           <a:p>
-            <a:pPr algn="ctr" indent="0" marL="0">
+            <a:pPr marL="0" indent="0" algn="ctr">
               <a:buNone/>
             </a:pPr>
             <a:r>
@@ -3045,7 +2773,7 @@
           <a:bodyPr wrap="square" rtlCol="0" anchor="ctr"/>
           <a:lstStyle/>
           <a:p>
-            <a:pPr indent="0" marL="0">
+            <a:pPr marL="0" indent="0">
               <a:buNone/>
             </a:pPr>
             <a:r>
@@ -3079,6 +2807,7 @@
         <a:solidFill>
           <a:srgbClr val="FFFFFF"/>
         </a:solidFill>
+        <a:effectLst/>
       </p:bgPr>
     </p:bg>
     <p:spTree>
@@ -3176,7 +2905,7 @@
           <a:bodyPr wrap="square" rtlCol="0" anchor="ctr"/>
           <a:lstStyle/>
           <a:p>
-            <a:pPr indent="0" marL="0">
+            <a:pPr marL="0" indent="0">
               <a:buNone/>
             </a:pPr>
             <a:r>
@@ -3210,16 +2939,34 @@
         </p:nvGraphicFramePr>
         <p:xfrm>
           <a:off x="594360" y="1554480"/>
-          <a:ext cx="6035040" cy="914400"/>
+          <a:ext cx="6035040" cy="2267712"/>
         </p:xfrm>
         <a:graphic>
           <a:graphicData uri="http://schemas.openxmlformats.org/drawingml/2006/table">
             <a:tbl>
               <a:tblPr/>
               <a:tblGrid>
-                <a:gridCol w="2743200"/>
-                <a:gridCol w="1645920"/>
-                <a:gridCol w="1645920"/>
+                <a:gridCol w="2743200">
+                  <a:extLst>
+                    <a:ext uri="{9D8B030D-6E8A-4147-A177-3AD203B41FA5}">
+                      <a16:colId xmlns:a16="http://schemas.microsoft.com/office/drawing/2014/main" val="20000"/>
+                    </a:ext>
+                  </a:extLst>
+                </a:gridCol>
+                <a:gridCol w="1645920">
+                  <a:extLst>
+                    <a:ext uri="{9D8B030D-6E8A-4147-A177-3AD203B41FA5}">
+                      <a16:colId xmlns:a16="http://schemas.microsoft.com/office/drawing/2014/main" val="20001"/>
+                    </a:ext>
+                  </a:extLst>
+                </a:gridCol>
+                <a:gridCol w="1645920">
+                  <a:extLst>
+                    <a:ext uri="{9D8B030D-6E8A-4147-A177-3AD203B41FA5}">
+                      <a16:colId xmlns:a16="http://schemas.microsoft.com/office/drawing/2014/main" val="20002"/>
+                    </a:ext>
+                  </a:extLst>
+                </a:gridCol>
               </a:tblGrid>
               <a:tr h="566928">
                 <a:tc>
@@ -3227,7 +2974,7 @@
                     <a:bodyPr/>
                     <a:lstStyle/>
                     <a:p>
-                      <a:pPr algn="ctr" indent="0" marL="0">
+                      <a:pPr marL="0" indent="0" algn="ctr">
                         <a:buNone/>
                       </a:pPr>
                       <a:r>
@@ -3248,7 +2995,7 @@
                       </a:endParaRPr>
                     </a:p>
                   </a:txBody>
-                  <a:tcPr marL="91440" marR="91440" marT="45720" marB="45720" anchor="ctr">
+                  <a:tcPr anchor="ctr">
                     <a:lnL w="12700" cap="flat" cmpd="sng" algn="ctr">
                       <a:solidFill>
                         <a:srgbClr val="D7D3F0"/>
@@ -3295,7 +3042,7 @@
                     <a:bodyPr/>
                     <a:lstStyle/>
                     <a:p>
-                      <a:pPr algn="ctr" indent="0" marL="0">
+                      <a:pPr marL="0" indent="0" algn="ctr">
                         <a:buNone/>
                       </a:pPr>
                       <a:r>
@@ -3316,7 +3063,7 @@
                       </a:endParaRPr>
                     </a:p>
                   </a:txBody>
-                  <a:tcPr marL="91440" marR="91440" marT="45720" marB="45720" anchor="ctr">
+                  <a:tcPr anchor="ctr">
                     <a:lnL w="12700" cap="flat" cmpd="sng" algn="ctr">
                       <a:solidFill>
                         <a:srgbClr val="D7D3F0"/>
@@ -3363,7 +3110,7 @@
                     <a:bodyPr/>
                     <a:lstStyle/>
                     <a:p>
-                      <a:pPr algn="ctr" indent="0" marL="0">
+                      <a:pPr marL="0" indent="0" algn="ctr">
                         <a:buNone/>
                       </a:pPr>
                       <a:r>
@@ -3384,7 +3131,7 @@
                       </a:endParaRPr>
                     </a:p>
                   </a:txBody>
-                  <a:tcPr marL="91440" marR="91440" marT="45720" marB="45720" anchor="ctr">
+                  <a:tcPr anchor="ctr">
                     <a:lnL w="12700" cap="flat" cmpd="sng" algn="ctr">
                       <a:solidFill>
                         <a:srgbClr val="D7D3F0"/>
@@ -3426,6 +3173,11 @@
                     </a:solidFill>
                   </a:tcPr>
                 </a:tc>
+                <a:extLst>
+                  <a:ext uri="{0D108BD9-81ED-4DB2-BD59-A6C34878D82A}">
+                    <a16:rowId xmlns:a16="http://schemas.microsoft.com/office/drawing/2014/main" val="10000"/>
+                  </a:ext>
+                </a:extLst>
               </a:tr>
               <a:tr h="566928">
                 <a:tc>
@@ -3433,7 +3185,7 @@
                     <a:bodyPr/>
                     <a:lstStyle/>
                     <a:p>
-                      <a:pPr algn="l" indent="0" marL="0">
+                      <a:pPr marL="0" indent="0" algn="l">
                         <a:buNone/>
                       </a:pPr>
                       <a:r>
@@ -3454,7 +3206,7 @@
                       </a:endParaRPr>
                     </a:p>
                   </a:txBody>
-                  <a:tcPr marL="91440" marR="91440" marT="45720" marB="45720" anchor="ctr">
+                  <a:tcPr anchor="ctr">
                     <a:lnL w="12700" cap="flat" cmpd="sng" algn="ctr">
                       <a:solidFill>
                         <a:srgbClr val="D7D3F0"/>
@@ -3501,7 +3253,7 @@
                     <a:bodyPr/>
                     <a:lstStyle/>
                     <a:p>
-                      <a:pPr algn="ctr" indent="0" marL="0">
+                      <a:pPr marL="0" indent="0" algn="ctr">
                         <a:buNone/>
                       </a:pPr>
                       <a:r>
@@ -3522,7 +3274,7 @@
                       </a:endParaRPr>
                     </a:p>
                   </a:txBody>
-                  <a:tcPr marL="91440" marR="91440" marT="45720" marB="45720" anchor="ctr">
+                  <a:tcPr anchor="ctr">
                     <a:lnL w="12700" cap="flat" cmpd="sng" algn="ctr">
                       <a:solidFill>
                         <a:srgbClr val="D7D3F0"/>
@@ -3569,7 +3321,7 @@
                     <a:bodyPr/>
                     <a:lstStyle/>
                     <a:p>
-                      <a:pPr algn="ctr" indent="0" marL="0">
+                      <a:pPr marL="0" indent="0" algn="ctr">
                         <a:buNone/>
                       </a:pPr>
                       <a:r>
@@ -3590,7 +3342,7 @@
                       </a:endParaRPr>
                     </a:p>
                   </a:txBody>
-                  <a:tcPr marL="91440" marR="91440" marT="45720" marB="45720" anchor="ctr">
+                  <a:tcPr anchor="ctr">
                     <a:lnL w="12700" cap="flat" cmpd="sng" algn="ctr">
                       <a:solidFill>
                         <a:srgbClr val="D7D3F0"/>
@@ -3632,6 +3384,11 @@
                     </a:solidFill>
                   </a:tcPr>
                 </a:tc>
+                <a:extLst>
+                  <a:ext uri="{0D108BD9-81ED-4DB2-BD59-A6C34878D82A}">
+                    <a16:rowId xmlns:a16="http://schemas.microsoft.com/office/drawing/2014/main" val="10001"/>
+                  </a:ext>
+                </a:extLst>
               </a:tr>
               <a:tr h="566928">
                 <a:tc>
@@ -3639,7 +3396,7 @@
                     <a:bodyPr/>
                     <a:lstStyle/>
                     <a:p>
-                      <a:pPr algn="l" indent="0" marL="0">
+                      <a:pPr marL="0" indent="0" algn="l">
                         <a:buNone/>
                       </a:pPr>
                       <a:r>
@@ -3660,7 +3417,7 @@
                       </a:endParaRPr>
                     </a:p>
                   </a:txBody>
-                  <a:tcPr marL="91440" marR="91440" marT="45720" marB="45720" anchor="ctr">
+                  <a:tcPr anchor="ctr">
                     <a:lnL w="12700" cap="flat" cmpd="sng" algn="ctr">
                       <a:solidFill>
                         <a:srgbClr val="D7D3F0"/>
@@ -3707,7 +3464,7 @@
                     <a:bodyPr/>
                     <a:lstStyle/>
                     <a:p>
-                      <a:pPr algn="ctr" indent="0" marL="0">
+                      <a:pPr marL="0" indent="0" algn="ctr">
                         <a:buNone/>
                       </a:pPr>
                       <a:r>
@@ -3728,7 +3485,7 @@
                       </a:endParaRPr>
                     </a:p>
                   </a:txBody>
-                  <a:tcPr marL="91440" marR="91440" marT="45720" marB="45720" anchor="ctr">
+                  <a:tcPr anchor="ctr">
                     <a:lnL w="12700" cap="flat" cmpd="sng" algn="ctr">
                       <a:solidFill>
                         <a:srgbClr val="D7D3F0"/>
@@ -3775,7 +3532,7 @@
                     <a:bodyPr/>
                     <a:lstStyle/>
                     <a:p>
-                      <a:pPr algn="ctr" indent="0" marL="0">
+                      <a:pPr marL="0" indent="0" algn="ctr">
                         <a:buNone/>
                       </a:pPr>
                       <a:r>
@@ -3796,7 +3553,7 @@
                       </a:endParaRPr>
                     </a:p>
                   </a:txBody>
-                  <a:tcPr marL="91440" marR="91440" marT="45720" marB="45720" anchor="ctr">
+                  <a:tcPr anchor="ctr">
                     <a:lnL w="12700" cap="flat" cmpd="sng" algn="ctr">
                       <a:solidFill>
                         <a:srgbClr val="D7D3F0"/>
@@ -3838,6 +3595,11 @@
                     </a:solidFill>
                   </a:tcPr>
                 </a:tc>
+                <a:extLst>
+                  <a:ext uri="{0D108BD9-81ED-4DB2-BD59-A6C34878D82A}">
+                    <a16:rowId xmlns:a16="http://schemas.microsoft.com/office/drawing/2014/main" val="10002"/>
+                  </a:ext>
+                </a:extLst>
               </a:tr>
               <a:tr h="566928">
                 <a:tc>
@@ -3845,7 +3607,7 @@
                     <a:bodyPr/>
                     <a:lstStyle/>
                     <a:p>
-                      <a:pPr algn="l" indent="0" marL="0">
+                      <a:pPr marL="0" indent="0" algn="l">
                         <a:buNone/>
                       </a:pPr>
                       <a:r>
@@ -3866,7 +3628,7 @@
                       </a:endParaRPr>
                     </a:p>
                   </a:txBody>
-                  <a:tcPr marL="91440" marR="91440" marT="45720" marB="45720" anchor="ctr">
+                  <a:tcPr anchor="ctr">
                     <a:lnL w="12700" cap="flat" cmpd="sng" algn="ctr">
                       <a:solidFill>
                         <a:srgbClr val="D7D3F0"/>
@@ -3913,7 +3675,7 @@
                     <a:bodyPr/>
                     <a:lstStyle/>
                     <a:p>
-                      <a:pPr algn="ctr" indent="0" marL="0">
+                      <a:pPr marL="0" indent="0" algn="ctr">
                         <a:buNone/>
                       </a:pPr>
                       <a:r>
@@ -3934,7 +3696,7 @@
                       </a:endParaRPr>
                     </a:p>
                   </a:txBody>
-                  <a:tcPr marL="91440" marR="91440" marT="45720" marB="45720" anchor="ctr">
+                  <a:tcPr anchor="ctr">
                     <a:lnL w="12700" cap="flat" cmpd="sng" algn="ctr">
                       <a:solidFill>
                         <a:srgbClr val="D7D3F0"/>
@@ -3981,7 +3743,7 @@
                     <a:bodyPr/>
                     <a:lstStyle/>
                     <a:p>
-                      <a:pPr algn="ctr" indent="0" marL="0">
+                      <a:pPr marL="0" indent="0" algn="ctr">
                         <a:buNone/>
                       </a:pPr>
                       <a:r>
@@ -4002,7 +3764,7 @@
                       </a:endParaRPr>
                     </a:p>
                   </a:txBody>
-                  <a:tcPr marL="91440" marR="91440" marT="45720" marB="45720" anchor="ctr">
+                  <a:tcPr anchor="ctr">
                     <a:lnL w="12700" cap="flat" cmpd="sng" algn="ctr">
                       <a:solidFill>
                         <a:srgbClr val="D7D3F0"/>
@@ -4044,6 +3806,11 @@
                     </a:solidFill>
                   </a:tcPr>
                 </a:tc>
+                <a:extLst>
+                  <a:ext uri="{0D108BD9-81ED-4DB2-BD59-A6C34878D82A}">
+                    <a16:rowId xmlns:a16="http://schemas.microsoft.com/office/drawing/2014/main" val="10003"/>
+                  </a:ext>
+                </a:extLst>
               </a:tr>
             </a:tbl>
           </a:graphicData>
@@ -4097,7 +3864,7 @@
           <a:bodyPr wrap="square" rtlCol="0" anchor="ctr"/>
           <a:lstStyle/>
           <a:p>
-            <a:pPr indent="0" marL="0">
+            <a:pPr marL="0" indent="0">
               <a:buNone/>
             </a:pPr>
             <a:r>
@@ -4248,7 +4015,7 @@
           <a:bodyPr wrap="square" rtlCol="0" anchor="ctr"/>
           <a:lstStyle/>
           <a:p>
-            <a:pPr indent="0" marL="0">
+            <a:pPr marL="0" indent="0">
               <a:buNone/>
             </a:pPr>
             <a:r>
@@ -4268,7 +4035,7 @@
       </p:sp>
       <p:sp>
         <p:nvSpPr>
-          <p:cNvPr id="12" name="Shape 9"/>
+          <p:cNvPr id="6" name="Shape 9"/>
           <p:cNvSpPr/>
           <p:nvPr/>
         </p:nvSpPr>
@@ -4307,7 +4074,7 @@
           <a:bodyPr wrap="square" rtlCol="0" anchor="ctr"/>
           <a:lstStyle/>
           <a:p>
-            <a:pPr algn="ctr" indent="0" marL="0">
+            <a:pPr marL="0" indent="0" algn="ctr">
               <a:buNone/>
             </a:pPr>
             <a:r>
@@ -4346,7 +4113,7 @@
           <a:bodyPr wrap="square" rtlCol="0" anchor="ctr"/>
           <a:lstStyle/>
           <a:p>
-            <a:pPr indent="0" marL="0">
+            <a:pPr marL="0" indent="0">
               <a:buNone/>
             </a:pPr>
             <a:r>
@@ -4380,6 +4147,7 @@
         <a:solidFill>
           <a:srgbClr val="FFFFFF"/>
         </a:solidFill>
+        <a:effectLst/>
       </p:bgPr>
     </p:bg>
     <p:spTree>
@@ -4477,7 +4245,7 @@
           <a:bodyPr wrap="square" rtlCol="0" anchor="ctr"/>
           <a:lstStyle/>
           <a:p>
-            <a:pPr indent="0" marL="0">
+            <a:pPr marL="0" indent="0">
               <a:buNone/>
             </a:pPr>
             <a:r>
@@ -4543,7 +4311,7 @@
           <a:bodyPr wrap="square" rtlCol="0" anchor="ctr"/>
           <a:lstStyle/>
           <a:p>
-            <a:pPr indent="0" marL="0">
+            <a:pPr marL="0" indent="0">
               <a:buNone/>
             </a:pPr>
             <a:r>
@@ -4694,7 +4462,7 @@
           <a:bodyPr wrap="square" rtlCol="0" anchor="ctr"/>
           <a:lstStyle/>
           <a:p>
-            <a:pPr indent="0" marL="0">
+            <a:pPr marL="0" indent="0">
               <a:buNone/>
             </a:pPr>
             <a:r>
@@ -4838,7 +4606,7 @@
           <a:bodyPr wrap="square" rtlCol="0" anchor="ctr"/>
           <a:lstStyle/>
           <a:p>
-            <a:pPr algn="ctr" indent="0" marL="0">
+            <a:pPr marL="0" indent="0" algn="ctr">
               <a:buNone/>
             </a:pPr>
             <a:r>
@@ -4877,7 +4645,7 @@
           <a:bodyPr wrap="square" rtlCol="0" anchor="ctr"/>
           <a:lstStyle/>
           <a:p>
-            <a:pPr indent="0" marL="0">
+            <a:pPr marL="0" indent="0">
               <a:buNone/>
             </a:pPr>
             <a:r>
@@ -4911,6 +4679,7 @@
         <a:solidFill>
           <a:srgbClr val="1E1B3A"/>
         </a:solidFill>
+        <a:effectLst/>
       </p:bgPr>
     </p:bg>
     <p:spTree>
@@ -5030,7 +4799,7 @@
           <a:bodyPr wrap="square" rtlCol="0" anchor="ctr"/>
           <a:lstStyle/>
           <a:p>
-            <a:pPr indent="0" marL="0">
+            <a:pPr marL="0" indent="0">
               <a:buNone/>
             </a:pPr>
             <a:r>
@@ -5195,7 +4964,7 @@
           <a:bodyPr wrap="square" rtlCol="0" anchor="ctr"/>
           <a:lstStyle/>
           <a:p>
-            <a:pPr indent="0" marL="0">
+            <a:pPr marL="0" indent="0">
               <a:buNone/>
             </a:pPr>
             <a:r>
@@ -5209,9 +4978,6 @@
               </a:rPr>
               <a:t>Future work: </a:t>
             </a:r>
-            <a:pPr indent="0" marL="0">
-              <a:buNone/>
-            </a:pPr>
             <a:r>
               <a:rPr lang="en-US" sz="2000" dirty="0">
                 <a:solidFill>
@@ -5251,15 +5017,15 @@
       </p:sp>
       <p:pic>
         <p:nvPicPr>
-          <p:cNvPr id="11" name="Image 0" descr="C:/Users/h/Desktop/Mini-project Fec/Mini-Project/hardware/imgs/FELCOM assembled.jpeg">    </p:cNvPr>
+          <p:cNvPr id="11" name="Image 0" descr="C:/Users/h/Desktop/Mini-project Fec/Mini-Project/hardware/imgs/FELCOM assembled.jpeg"/>
           <p:cNvPicPr>
             <a:picLocks noChangeAspect="1"/>
           </p:cNvPicPr>
           <p:nvPr/>
         </p:nvPicPr>
         <p:blipFill>
-          <a:blip r:embed="rId1"/>
-          <a:srcRect l="0" r="0" t="0" b="0"/>
+          <a:blip r:embed="rId3"/>
+          <a:srcRect/>
           <a:stretch/>
         </p:blipFill>
         <p:spPr>
@@ -5288,6 +5054,7 @@
         <a:solidFill>
           <a:srgbClr val="FFFFFF"/>
         </a:solidFill>
+        <a:effectLst/>
       </p:bgPr>
     </p:bg>
     <p:spTree>
@@ -5385,7 +5152,7 @@
           <a:bodyPr wrap="square" rtlCol="0" anchor="ctr"/>
           <a:lstStyle/>
           <a:p>
-            <a:pPr indent="0" marL="0">
+            <a:pPr marL="0" indent="0">
               <a:buNone/>
             </a:pPr>
             <a:r>
@@ -5424,7 +5191,7 @@
           <a:bodyPr wrap="square" rtlCol="0" anchor="t"/>
           <a:lstStyle/>
           <a:p>
-            <a:pPr indent="0" marL="0">
+            <a:pPr marL="0" indent="0">
               <a:buNone/>
             </a:pPr>
             <a:r>
@@ -5438,13 +5205,35 @@
               </a:rPr>
               <a:t>[1]  </a:t>
             </a:r>
-            <a:pPr indent="0" marL="0">
-              <a:spcAft>
-                <a:spcPts val="1200"/>
-              </a:spcAft>
+            <a:r>
+              <a:rPr lang="en-US" sz="1700" dirty="0">
+                <a:solidFill>
+                  <a:srgbClr val="2A2A33"/>
+                </a:solidFill>
+                <a:latin typeface="Segoe UI" pitchFamily="34" charset="0"/>
+                <a:ea typeface="Segoe UI" pitchFamily="34" charset="-122"/>
+                <a:cs typeface="Segoe UI" pitchFamily="34" charset="-120"/>
+              </a:rPr>
+              <a:t>Nordic Semiconductor, nRF24L01+ Transceiver Product Specification.</a:t>
+            </a:r>
+            <a:endParaRPr lang="en-US" sz="1700" dirty="0"/>
+          </a:p>
+          <a:p>
+            <a:pPr marL="0" indent="0">
               <a:buNone/>
             </a:pPr>
             <a:r>
+              <a:rPr lang="en-US" sz="1700" b="1" dirty="0">
+                <a:solidFill>
+                  <a:srgbClr val="4F46E5"/>
+                </a:solidFill>
+                <a:latin typeface="Segoe UI" pitchFamily="34" charset="0"/>
+                <a:ea typeface="Segoe UI" pitchFamily="34" charset="-122"/>
+                <a:cs typeface="Segoe UI" pitchFamily="34" charset="-120"/>
+              </a:rPr>
+              <a:t>[2]  </a:t>
+            </a:r>
+            <a:r>
               <a:rPr lang="en-US" sz="1700" dirty="0">
                 <a:solidFill>
                   <a:srgbClr val="2A2A33"/>
@@ -5453,12 +5242,12 @@
                 <a:ea typeface="Segoe UI" pitchFamily="34" charset="-122"/>
                 <a:cs typeface="Segoe UI" pitchFamily="34" charset="-120"/>
               </a:rPr>
-              <a:t>Nordic Semiconductor, nRF24L01+ Transceiver Product Specification.</a:t>
+              <a:t>Espressif Systems, ESP32 Technical Reference Manual and Datasheet.</a:t>
             </a:r>
             <a:endParaRPr lang="en-US" sz="1700" dirty="0"/>
           </a:p>
           <a:p>
-            <a:pPr indent="0" marL="0">
+            <a:pPr marL="0" indent="0">
               <a:buNone/>
             </a:pPr>
             <a:r>
@@ -5470,15 +5259,37 @@
                 <a:ea typeface="Segoe UI" pitchFamily="34" charset="-122"/>
                 <a:cs typeface="Segoe UI" pitchFamily="34" charset="-120"/>
               </a:rPr>
-              <a:t>[2]  </a:t>
-            </a:r>
-            <a:pPr indent="0" marL="0">
-              <a:spcAft>
-                <a:spcPts val="1200"/>
-              </a:spcAft>
+              <a:t>[3]  </a:t>
+            </a:r>
+            <a:r>
+              <a:rPr lang="en-US" sz="1700" dirty="0">
+                <a:solidFill>
+                  <a:srgbClr val="2A2A33"/>
+                </a:solidFill>
+                <a:latin typeface="Segoe UI" pitchFamily="34" charset="0"/>
+                <a:ea typeface="Segoe UI" pitchFamily="34" charset="-122"/>
+                <a:cs typeface="Segoe UI" pitchFamily="34" charset="-120"/>
+              </a:rPr>
+              <a:t>InvenSense (TDK), INMP441 I2S Microphone Datasheet.</a:t>
+            </a:r>
+            <a:endParaRPr lang="en-US" sz="1700" dirty="0"/>
+          </a:p>
+          <a:p>
+            <a:pPr marL="0" indent="0">
               <a:buNone/>
             </a:pPr>
             <a:r>
+              <a:rPr lang="en-US" sz="1700" b="1" dirty="0">
+                <a:solidFill>
+                  <a:srgbClr val="4F46E5"/>
+                </a:solidFill>
+                <a:latin typeface="Segoe UI" pitchFamily="34" charset="0"/>
+                <a:ea typeface="Segoe UI" pitchFamily="34" charset="-122"/>
+                <a:cs typeface="Segoe UI" pitchFamily="34" charset="-120"/>
+              </a:rPr>
+              <a:t>[4]  </a:t>
+            </a:r>
+            <a:r>
               <a:rPr lang="en-US" sz="1700" dirty="0">
                 <a:solidFill>
                   <a:srgbClr val="2A2A33"/>
@@ -5487,12 +5298,12 @@
                 <a:ea typeface="Segoe UI" pitchFamily="34" charset="-122"/>
                 <a:cs typeface="Segoe UI" pitchFamily="34" charset="-120"/>
               </a:rPr>
-              <a:t>Espressif Systems, ESP32 Technical Reference Manual and Datasheet.</a:t>
+              <a:t>Texas Instruments, LM386 Audio Power Amplifier Datasheet.</a:t>
             </a:r>
             <a:endParaRPr lang="en-US" sz="1700" dirty="0"/>
           </a:p>
           <a:p>
-            <a:pPr indent="0" marL="0">
+            <a:pPr marL="0" indent="0">
               <a:buNone/>
             </a:pPr>
             <a:r>
@@ -5504,15 +5315,37 @@
                 <a:ea typeface="Segoe UI" pitchFamily="34" charset="-122"/>
                 <a:cs typeface="Segoe UI" pitchFamily="34" charset="-120"/>
               </a:rPr>
-              <a:t>[3]  </a:t>
-            </a:r>
-            <a:pPr indent="0" marL="0">
-              <a:spcAft>
-                <a:spcPts val="1200"/>
-              </a:spcAft>
+              <a:t>[5]  </a:t>
+            </a:r>
+            <a:r>
+              <a:rPr lang="en-US" sz="1700" dirty="0">
+                <a:solidFill>
+                  <a:srgbClr val="2A2A33"/>
+                </a:solidFill>
+                <a:latin typeface="Segoe UI" pitchFamily="34" charset="0"/>
+                <a:ea typeface="Segoe UI" pitchFamily="34" charset="-122"/>
+                <a:cs typeface="Segoe UI" pitchFamily="34" charset="-120"/>
+              </a:rPr>
+              <a:t>TMRh20, RF24: Optimized driver for nRF24L01(+) (open source).</a:t>
+            </a:r>
+            <a:endParaRPr lang="en-US" sz="1700" dirty="0"/>
+          </a:p>
+          <a:p>
+            <a:pPr marL="0" indent="0">
               <a:buNone/>
             </a:pPr>
             <a:r>
+              <a:rPr lang="en-US" sz="1700" b="1" dirty="0">
+                <a:solidFill>
+                  <a:srgbClr val="4F46E5"/>
+                </a:solidFill>
+                <a:latin typeface="Segoe UI" pitchFamily="34" charset="0"/>
+                <a:ea typeface="Segoe UI" pitchFamily="34" charset="-122"/>
+                <a:cs typeface="Segoe UI" pitchFamily="34" charset="-120"/>
+              </a:rPr>
+              <a:t>[6]  </a:t>
+            </a:r>
+            <a:r>
               <a:rPr lang="en-US" sz="1700" dirty="0">
                 <a:solidFill>
                   <a:srgbClr val="2A2A33"/>
@@ -5521,12 +5354,12 @@
                 <a:ea typeface="Segoe UI" pitchFamily="34" charset="-122"/>
                 <a:cs typeface="Segoe UI" pitchFamily="34" charset="-120"/>
               </a:rPr>
-              <a:t>InvenSense (TDK), INMP441 I2S Microphone Datasheet.</a:t>
+              <a:t>Lamarr &amp; Antheil, Secret Communication System, U.S. Patent 2,292,387, 1942.</a:t>
             </a:r>
             <a:endParaRPr lang="en-US" sz="1700" dirty="0"/>
           </a:p>
           <a:p>
-            <a:pPr indent="0" marL="0">
+            <a:pPr marL="0" indent="0">
               <a:buNone/>
             </a:pPr>
             <a:r>
@@ -5538,32 +5371,26 @@
                 <a:ea typeface="Segoe UI" pitchFamily="34" charset="-122"/>
                 <a:cs typeface="Segoe UI" pitchFamily="34" charset="-120"/>
               </a:rPr>
-              <a:t>[4]  </a:t>
-            </a:r>
-            <a:pPr indent="0" marL="0">
-              <a:spcAft>
-                <a:spcPts val="1200"/>
-              </a:spcAft>
+              <a:t>[7]  </a:t>
+            </a:r>
+            <a:r>
+              <a:rPr lang="en-US" sz="1700" dirty="0">
+                <a:solidFill>
+                  <a:srgbClr val="2A2A33"/>
+                </a:solidFill>
+                <a:latin typeface="Segoe UI" pitchFamily="34" charset="0"/>
+                <a:ea typeface="Segoe UI" pitchFamily="34" charset="-122"/>
+                <a:cs typeface="Segoe UI" pitchFamily="34" charset="-120"/>
+              </a:rPr>
+              <a:t>ITU-T Recommendation V.41, CRC-16-CCITT.</a:t>
+            </a:r>
+            <a:endParaRPr lang="en-US" sz="1700" dirty="0"/>
+          </a:p>
+          <a:p>
+            <a:pPr marL="0" indent="0">
               <a:buNone/>
             </a:pPr>
             <a:r>
-              <a:rPr lang="en-US" sz="1700" dirty="0">
-                <a:solidFill>
-                  <a:srgbClr val="2A2A33"/>
-                </a:solidFill>
-                <a:latin typeface="Segoe UI" pitchFamily="34" charset="0"/>
-                <a:ea typeface="Segoe UI" pitchFamily="34" charset="-122"/>
-                <a:cs typeface="Segoe UI" pitchFamily="34" charset="-120"/>
-              </a:rPr>
-              <a:t>Texas Instruments, LM386 Audio Power Amplifier Datasheet.</a:t>
-            </a:r>
-            <a:endParaRPr lang="en-US" sz="1700" dirty="0"/>
-          </a:p>
-          <a:p>
-            <a:pPr indent="0" marL="0">
-              <a:buNone/>
-            </a:pPr>
-            <a:r>
               <a:rPr lang="en-US" sz="1700" b="1" dirty="0">
                 <a:solidFill>
                   <a:srgbClr val="4F46E5"/>
@@ -5572,116 +5399,8 @@
                 <a:ea typeface="Segoe UI" pitchFamily="34" charset="-122"/>
                 <a:cs typeface="Segoe UI" pitchFamily="34" charset="-120"/>
               </a:rPr>
-              <a:t>[5]  </a:t>
-            </a:r>
-            <a:pPr indent="0" marL="0">
-              <a:spcAft>
-                <a:spcPts val="1200"/>
-              </a:spcAft>
-              <a:buNone/>
-            </a:pPr>
-            <a:r>
-              <a:rPr lang="en-US" sz="1700" dirty="0">
-                <a:solidFill>
-                  <a:srgbClr val="2A2A33"/>
-                </a:solidFill>
-                <a:latin typeface="Segoe UI" pitchFamily="34" charset="0"/>
-                <a:ea typeface="Segoe UI" pitchFamily="34" charset="-122"/>
-                <a:cs typeface="Segoe UI" pitchFamily="34" charset="-120"/>
-              </a:rPr>
-              <a:t>TMRh20, RF24: Optimized driver for nRF24L01(+) (open source).</a:t>
-            </a:r>
-            <a:endParaRPr lang="en-US" sz="1700" dirty="0"/>
-          </a:p>
-          <a:p>
-            <a:pPr indent="0" marL="0">
-              <a:buNone/>
-            </a:pPr>
-            <a:r>
-              <a:rPr lang="en-US" sz="1700" b="1" dirty="0">
-                <a:solidFill>
-                  <a:srgbClr val="4F46E5"/>
-                </a:solidFill>
-                <a:latin typeface="Segoe UI" pitchFamily="34" charset="0"/>
-                <a:ea typeface="Segoe UI" pitchFamily="34" charset="-122"/>
-                <a:cs typeface="Segoe UI" pitchFamily="34" charset="-120"/>
-              </a:rPr>
-              <a:t>[6]  </a:t>
-            </a:r>
-            <a:pPr indent="0" marL="0">
-              <a:spcAft>
-                <a:spcPts val="1200"/>
-              </a:spcAft>
-              <a:buNone/>
-            </a:pPr>
-            <a:r>
-              <a:rPr lang="en-US" sz="1700" dirty="0">
-                <a:solidFill>
-                  <a:srgbClr val="2A2A33"/>
-                </a:solidFill>
-                <a:latin typeface="Segoe UI" pitchFamily="34" charset="0"/>
-                <a:ea typeface="Segoe UI" pitchFamily="34" charset="-122"/>
-                <a:cs typeface="Segoe UI" pitchFamily="34" charset="-120"/>
-              </a:rPr>
-              <a:t>Lamarr &amp; Antheil, Secret Communication System, U.S. Patent 2,292,387, 1942.</a:t>
-            </a:r>
-            <a:endParaRPr lang="en-US" sz="1700" dirty="0"/>
-          </a:p>
-          <a:p>
-            <a:pPr indent="0" marL="0">
-              <a:buNone/>
-            </a:pPr>
-            <a:r>
-              <a:rPr lang="en-US" sz="1700" b="1" dirty="0">
-                <a:solidFill>
-                  <a:srgbClr val="4F46E5"/>
-                </a:solidFill>
-                <a:latin typeface="Segoe UI" pitchFamily="34" charset="0"/>
-                <a:ea typeface="Segoe UI" pitchFamily="34" charset="-122"/>
-                <a:cs typeface="Segoe UI" pitchFamily="34" charset="-120"/>
-              </a:rPr>
-              <a:t>[7]  </a:t>
-            </a:r>
-            <a:pPr indent="0" marL="0">
-              <a:spcAft>
-                <a:spcPts val="1200"/>
-              </a:spcAft>
-              <a:buNone/>
-            </a:pPr>
-            <a:r>
-              <a:rPr lang="en-US" sz="1700" dirty="0">
-                <a:solidFill>
-                  <a:srgbClr val="2A2A33"/>
-                </a:solidFill>
-                <a:latin typeface="Segoe UI" pitchFamily="34" charset="0"/>
-                <a:ea typeface="Segoe UI" pitchFamily="34" charset="-122"/>
-                <a:cs typeface="Segoe UI" pitchFamily="34" charset="-120"/>
-              </a:rPr>
-              <a:t>ITU-T Recommendation V.41, CRC-16-CCITT.</a:t>
-            </a:r>
-            <a:endParaRPr lang="en-US" sz="1700" dirty="0"/>
-          </a:p>
-          <a:p>
-            <a:pPr indent="0" marL="0">
-              <a:buNone/>
-            </a:pPr>
-            <a:r>
-              <a:rPr lang="en-US" sz="1700" b="1" dirty="0">
-                <a:solidFill>
-                  <a:srgbClr val="4F46E5"/>
-                </a:solidFill>
-                <a:latin typeface="Segoe UI" pitchFamily="34" charset="0"/>
-                <a:ea typeface="Segoe UI" pitchFamily="34" charset="-122"/>
-                <a:cs typeface="Segoe UI" pitchFamily="34" charset="-120"/>
-              </a:rPr>
               <a:t>[8]  </a:t>
             </a:r>
-            <a:pPr indent="0" marL="0">
-              <a:spcAft>
-                <a:spcPts val="1200"/>
-              </a:spcAft>
-              <a:buNone/>
-            </a:pPr>
             <a:r>
               <a:rPr lang="en-US" sz="1700" dirty="0">
                 <a:solidFill>
@@ -5738,7 +5457,7 @@
           <a:bodyPr wrap="square" rtlCol="0" anchor="ctr"/>
           <a:lstStyle/>
           <a:p>
-            <a:pPr algn="ctr" indent="0" marL="0">
+            <a:pPr marL="0" indent="0" algn="ctr">
               <a:buNone/>
             </a:pPr>
             <a:r>
@@ -5777,7 +5496,7 @@
           <a:bodyPr wrap="square" rtlCol="0" anchor="ctr"/>
           <a:lstStyle/>
           <a:p>
-            <a:pPr indent="0" marL="0">
+            <a:pPr marL="0" indent="0">
               <a:buNone/>
             </a:pPr>
             <a:r>
@@ -5811,6 +5530,7 @@
         <a:solidFill>
           <a:srgbClr val="1E1B3A"/>
         </a:solidFill>
+        <a:effectLst/>
       </p:bgPr>
     </p:bg>
     <p:spTree>
@@ -5952,7 +5672,7 @@
           <a:bodyPr wrap="square" rtlCol="0" anchor="ctr"/>
           <a:lstStyle/>
           <a:p>
-            <a:pPr indent="0" marL="0">
+            <a:pPr marL="0" indent="0">
               <a:buNone/>
             </a:pPr>
             <a:r>
@@ -5998,7 +5718,7 @@
         </p:nvSpPr>
         <p:spPr>
           <a:xfrm>
-            <a:off x="822960" y="2651760"/>
+            <a:off x="822960" y="2560320"/>
             <a:ext cx="10424160" cy="2011680"/>
           </a:xfrm>
           <a:prstGeom prst="rect">
@@ -6011,46 +5731,137 @@
           <a:bodyPr wrap="square" rtlCol="0" anchor="t"/>
           <a:lstStyle/>
           <a:p>
-            <a:pPr marL="254000" indent="-254000">
+            <a:pPr>
               <a:spcAft>
                 <a:spcPts val="1200"/>
               </a:spcAft>
               <a:buSzPct val="100000"/>
-              <a:buChar char="•"/>
-            </a:pPr>
-            <a:r>
-              <a:rPr lang="en-US" sz="2300" dirty="0">
-                <a:solidFill>
-                  <a:srgbClr val="FFFFFF"/>
-                </a:solidFill>
-                <a:latin typeface="Segoe UI" pitchFamily="34" charset="0"/>
-                <a:ea typeface="Segoe UI" pitchFamily="34" charset="-122"/>
-                <a:cs typeface="Segoe UI" pitchFamily="34" charset="-120"/>
-              </a:rPr>
-              <a:t>We thank our supervisor, Dr. Hadi Jerdek, for his guidance throughout the project.</a:t>
-            </a:r>
-            <a:endParaRPr lang="en-US" sz="2300" dirty="0"/>
-          </a:p>
-          <a:p>
-            <a:pPr marL="254000" indent="-254000">
+            </a:pPr>
+            <a:r>
+              <a:rPr lang="en-US" sz="2400" dirty="0">
+                <a:solidFill>
+                  <a:schemeClr val="bg1"/>
+                </a:solidFill>
+              </a:rPr>
+              <a:t>We would like to </a:t>
+            </a:r>
+            <a:r>
+              <a:rPr lang="en-US" sz="2400" dirty="0" smtClean="0">
+                <a:solidFill>
+                  <a:schemeClr val="bg1"/>
+                </a:solidFill>
+              </a:rPr>
+              <a:t>thank Dr</a:t>
+            </a:r>
+            <a:r>
+              <a:rPr lang="en-US" sz="2400" dirty="0">
+                <a:solidFill>
+                  <a:schemeClr val="bg1"/>
+                </a:solidFill>
+              </a:rPr>
+              <a:t>. </a:t>
+            </a:r>
+            <a:r>
+              <a:rPr lang="en-US" sz="2400" dirty="0" err="1">
+                <a:solidFill>
+                  <a:schemeClr val="bg1"/>
+                </a:solidFill>
+              </a:rPr>
+              <a:t>Hadi</a:t>
+            </a:r>
+            <a:r>
+              <a:rPr lang="en-US" sz="2400" dirty="0">
+                <a:solidFill>
+                  <a:schemeClr val="bg1"/>
+                </a:solidFill>
+              </a:rPr>
+              <a:t> </a:t>
+            </a:r>
+            <a:r>
+              <a:rPr lang="en-US" sz="2400" dirty="0" err="1">
+                <a:solidFill>
+                  <a:schemeClr val="bg1"/>
+                </a:solidFill>
+              </a:rPr>
+              <a:t>Jerdek</a:t>
+            </a:r>
+            <a:r>
+              <a:rPr lang="en-US" sz="2400" dirty="0">
+                <a:solidFill>
+                  <a:schemeClr val="bg1"/>
+                </a:solidFill>
+              </a:rPr>
+              <a:t>, for his supervision of this project and for the valuable knowledge he shared with us through the telecommunications courses he taught</a:t>
+            </a:r>
+            <a:r>
+              <a:rPr lang="en-US" sz="2400" dirty="0" smtClean="0">
+                <a:solidFill>
+                  <a:schemeClr val="bg1"/>
+                </a:solidFill>
+              </a:rPr>
+              <a:t>.</a:t>
+            </a:r>
+          </a:p>
+          <a:p>
+            <a:pPr>
               <a:spcAft>
                 <a:spcPts val="1200"/>
               </a:spcAft>
               <a:buSzPct val="100000"/>
-              <a:buChar char="•"/>
-            </a:pPr>
-            <a:r>
-              <a:rPr lang="en-US" sz="2300" dirty="0">
-                <a:solidFill>
-                  <a:srgbClr val="FFFFFF"/>
-                </a:solidFill>
-                <a:latin typeface="Segoe UI" pitchFamily="34" charset="0"/>
-                <a:ea typeface="Segoe UI" pitchFamily="34" charset="-122"/>
-                <a:cs typeface="Segoe UI" pitchFamily="34" charset="-120"/>
-              </a:rPr>
-              <a:t>We thank the Lebanese University, Faculty of Engineering, for its support and resources.</a:t>
-            </a:r>
-            <a:endParaRPr lang="en-US" sz="2300" dirty="0"/>
+            </a:pPr>
+            <a:r>
+              <a:rPr lang="en-US" sz="2400" dirty="0">
+                <a:solidFill>
+                  <a:schemeClr val="bg1"/>
+                </a:solidFill>
+              </a:rPr>
+              <a:t>We </a:t>
+            </a:r>
+            <a:r>
+              <a:rPr lang="en-US" sz="2400" dirty="0" smtClean="0">
+                <a:solidFill>
+                  <a:schemeClr val="bg1"/>
+                </a:solidFill>
+              </a:rPr>
+              <a:t>also thank </a:t>
+            </a:r>
+            <a:r>
+              <a:rPr lang="en-US" sz="2400" dirty="0">
+                <a:solidFill>
+                  <a:schemeClr val="bg1"/>
+                </a:solidFill>
+              </a:rPr>
+              <a:t>the </a:t>
+            </a:r>
+            <a:r>
+              <a:rPr lang="en-US" sz="2400" dirty="0" smtClean="0">
+                <a:solidFill>
+                  <a:schemeClr val="bg1"/>
+                </a:solidFill>
+              </a:rPr>
+              <a:t>Lebanese University </a:t>
+            </a:r>
+            <a:r>
+              <a:rPr lang="en-US" sz="2400" dirty="0">
+                <a:solidFill>
+                  <a:schemeClr val="bg1"/>
+                </a:solidFill>
+              </a:rPr>
+              <a:t>for allowing us to use its open air to test our </a:t>
+            </a:r>
+            <a:r>
+              <a:rPr lang="en-US" sz="2400" dirty="0" smtClean="0">
+                <a:solidFill>
+                  <a:schemeClr val="bg1"/>
+                </a:solidFill>
+              </a:rPr>
+              <a:t>devices.</a:t>
+            </a:r>
+            <a:endParaRPr lang="en-US" sz="2300" dirty="0">
+              <a:solidFill>
+                <a:schemeClr val="bg1"/>
+              </a:solidFill>
+            </a:endParaRPr>
           </a:p>
         </p:txBody>
       </p:sp>
@@ -6075,7 +5886,7 @@
           <a:bodyPr wrap="square" rtlCol="0" anchor="ctr"/>
           <a:lstStyle/>
           <a:p>
-            <a:pPr indent="0" marL="0">
+            <a:pPr marL="0" indent="0">
               <a:buNone/>
             </a:pPr>
             <a:r>
@@ -6109,6 +5920,7 @@
         <a:solidFill>
           <a:srgbClr val="FFFFFF"/>
         </a:solidFill>
+        <a:effectLst/>
       </p:bgPr>
     </p:bg>
     <p:spTree>
@@ -6206,7 +6018,7 @@
           <a:bodyPr wrap="square" rtlCol="0" anchor="ctr"/>
           <a:lstStyle/>
           <a:p>
-            <a:pPr indent="0" marL="0">
+            <a:pPr marL="0" indent="0">
               <a:buNone/>
             </a:pPr>
             <a:r>
@@ -6245,7 +6057,7 @@
           <a:bodyPr wrap="square" rtlCol="0" anchor="t"/>
           <a:lstStyle/>
           <a:p>
-            <a:pPr indent="0" marL="0">
+            <a:pPr marL="0" indent="0">
               <a:buNone/>
             </a:pPr>
             <a:r>
@@ -6259,13 +6071,35 @@
               </a:rPr>
               <a:t>1  </a:t>
             </a:r>
-            <a:pPr indent="0" marL="0">
-              <a:spcAft>
-                <a:spcPts val="1800"/>
-              </a:spcAft>
+            <a:r>
+              <a:rPr lang="en-US" sz="2300" dirty="0">
+                <a:solidFill>
+                  <a:srgbClr val="2A2A33"/>
+                </a:solidFill>
+                <a:latin typeface="Segoe UI" pitchFamily="34" charset="0"/>
+                <a:ea typeface="Segoe UI" pitchFamily="34" charset="-122"/>
+                <a:cs typeface="Segoe UI" pitchFamily="34" charset="-120"/>
+              </a:rPr>
+              <a:t>Motivation &amp; goals</a:t>
+            </a:r>
+            <a:endParaRPr lang="en-US" sz="2300" dirty="0"/>
+          </a:p>
+          <a:p>
+            <a:pPr marL="0" indent="0">
               <a:buNone/>
             </a:pPr>
             <a:r>
+              <a:rPr lang="en-US" sz="2300" b="1" dirty="0">
+                <a:solidFill>
+                  <a:srgbClr val="F59E0B"/>
+                </a:solidFill>
+                <a:latin typeface="Segoe UI" pitchFamily="34" charset="0"/>
+                <a:ea typeface="Segoe UI" pitchFamily="34" charset="-122"/>
+                <a:cs typeface="Segoe UI" pitchFamily="34" charset="-120"/>
+              </a:rPr>
+              <a:t>2  </a:t>
+            </a:r>
+            <a:r>
               <a:rPr lang="en-US" sz="2300" dirty="0">
                 <a:solidFill>
                   <a:srgbClr val="2A2A33"/>
@@ -6274,85 +6108,45 @@
                 <a:ea typeface="Segoe UI" pitchFamily="34" charset="-122"/>
                 <a:cs typeface="Segoe UI" pitchFamily="34" charset="-120"/>
               </a:rPr>
-              <a:t>Motivation &amp; goals</a:t>
+              <a:t>System overview</a:t>
             </a:r>
             <a:endParaRPr lang="en-US" sz="2300" dirty="0"/>
           </a:p>
           <a:p>
-            <a:pPr indent="0" marL="0">
+            <a:pPr marL="0" indent="0">
               <a:buNone/>
             </a:pPr>
             <a:r>
               <a:rPr lang="en-US" sz="2300" b="1" dirty="0">
                 <a:solidFill>
-                  <a:srgbClr val="F59E0B"/>
-                </a:solidFill>
-                <a:latin typeface="Segoe UI" pitchFamily="34" charset="0"/>
-                <a:ea typeface="Segoe UI" pitchFamily="34" charset="-122"/>
-                <a:cs typeface="Segoe UI" pitchFamily="34" charset="-120"/>
-              </a:rPr>
-              <a:t>2  </a:t>
-            </a:r>
-            <a:pPr indent="0" marL="0">
-              <a:spcAft>
-                <a:spcPts val="1800"/>
-              </a:spcAft>
+                  <a:srgbClr val="7C3AED"/>
+                </a:solidFill>
+                <a:latin typeface="Segoe UI" pitchFamily="34" charset="0"/>
+                <a:ea typeface="Segoe UI" pitchFamily="34" charset="-122"/>
+                <a:cs typeface="Segoe UI" pitchFamily="34" charset="-120"/>
+              </a:rPr>
+              <a:t>3  </a:t>
+            </a:r>
+            <a:r>
+              <a:rPr lang="en-US" sz="2300" dirty="0">
+                <a:solidFill>
+                  <a:srgbClr val="2A2A33"/>
+                </a:solidFill>
+                <a:latin typeface="Segoe UI" pitchFamily="34" charset="0"/>
+                <a:ea typeface="Segoe UI" pitchFamily="34" charset="-122"/>
+                <a:cs typeface="Segoe UI" pitchFamily="34" charset="-120"/>
+              </a:rPr>
+              <a:t>Frequency hopping &amp; sync</a:t>
+            </a:r>
+            <a:endParaRPr lang="en-US" sz="2300" dirty="0"/>
+          </a:p>
+          <a:p>
+            <a:pPr marL="0" indent="0">
               <a:buNone/>
             </a:pPr>
             <a:r>
-              <a:rPr lang="en-US" sz="2300" dirty="0">
-                <a:solidFill>
-                  <a:srgbClr val="2A2A33"/>
-                </a:solidFill>
-                <a:latin typeface="Segoe UI" pitchFamily="34" charset="0"/>
-                <a:ea typeface="Segoe UI" pitchFamily="34" charset="-122"/>
-                <a:cs typeface="Segoe UI" pitchFamily="34" charset="-120"/>
-              </a:rPr>
-              <a:t>System overview</a:t>
-            </a:r>
-            <a:endParaRPr lang="en-US" sz="2300" dirty="0"/>
-          </a:p>
-          <a:p>
-            <a:pPr indent="0" marL="0">
-              <a:buNone/>
-            </a:pPr>
-            <a:r>
               <a:rPr lang="en-US" sz="2300" b="1" dirty="0">
                 <a:solidFill>
-                  <a:srgbClr val="7C3AED"/>
-                </a:solidFill>
-                <a:latin typeface="Segoe UI" pitchFamily="34" charset="0"/>
-                <a:ea typeface="Segoe UI" pitchFamily="34" charset="-122"/>
-                <a:cs typeface="Segoe UI" pitchFamily="34" charset="-120"/>
-              </a:rPr>
-              <a:t>3  </a:t>
-            </a:r>
-            <a:pPr indent="0" marL="0">
-              <a:spcAft>
-                <a:spcPts val="1800"/>
-              </a:spcAft>
-              <a:buNone/>
-            </a:pPr>
-            <a:r>
-              <a:rPr lang="en-US" sz="2300" dirty="0">
-                <a:solidFill>
-                  <a:srgbClr val="2A2A33"/>
-                </a:solidFill>
-                <a:latin typeface="Segoe UI" pitchFamily="34" charset="0"/>
-                <a:ea typeface="Segoe UI" pitchFamily="34" charset="-122"/>
-                <a:cs typeface="Segoe UI" pitchFamily="34" charset="-120"/>
-              </a:rPr>
-              <a:t>Frequency hopping &amp; sync</a:t>
-            </a:r>
-            <a:endParaRPr lang="en-US" sz="2300" dirty="0"/>
-          </a:p>
-          <a:p>
-            <a:pPr indent="0" marL="0">
-              <a:buNone/>
-            </a:pPr>
-            <a:r>
-              <a:rPr lang="en-US" sz="2300" b="1" dirty="0">
-                <a:solidFill>
                   <a:srgbClr val="06B6D4"/>
                 </a:solidFill>
                 <a:latin typeface="Segoe UI" pitchFamily="34" charset="0"/>
@@ -6361,12 +6155,6 @@
               </a:rPr>
               <a:t>4  </a:t>
             </a:r>
-            <a:pPr indent="0" marL="0">
-              <a:spcAft>
-                <a:spcPts val="1800"/>
-              </a:spcAft>
-              <a:buNone/>
-            </a:pPr>
             <a:r>
               <a:rPr lang="en-US" sz="2300" dirty="0">
                 <a:solidFill>
@@ -6403,7 +6191,7 @@
           <a:bodyPr wrap="square" rtlCol="0" anchor="t"/>
           <a:lstStyle/>
           <a:p>
-            <a:pPr indent="0" marL="0">
+            <a:pPr marL="0" indent="0">
               <a:buNone/>
             </a:pPr>
             <a:r>
@@ -6417,13 +6205,35 @@
               </a:rPr>
               <a:t>5  </a:t>
             </a:r>
-            <a:pPr indent="0" marL="0">
-              <a:spcAft>
-                <a:spcPts val="1800"/>
-              </a:spcAft>
+            <a:r>
+              <a:rPr lang="en-US" sz="2300" dirty="0">
+                <a:solidFill>
+                  <a:srgbClr val="2A2A33"/>
+                </a:solidFill>
+                <a:latin typeface="Segoe UI" pitchFamily="34" charset="0"/>
+                <a:ea typeface="Segoe UI" pitchFamily="34" charset="-122"/>
+                <a:cs typeface="Segoe UI" pitchFamily="34" charset="-120"/>
+              </a:rPr>
+              <a:t>Forward error correction</a:t>
+            </a:r>
+            <a:endParaRPr lang="en-US" sz="2300" dirty="0"/>
+          </a:p>
+          <a:p>
+            <a:pPr marL="0" indent="0">
               <a:buNone/>
             </a:pPr>
             <a:r>
+              <a:rPr lang="en-US" sz="2300" b="1" dirty="0">
+                <a:solidFill>
+                  <a:srgbClr val="F59E0B"/>
+                </a:solidFill>
+                <a:latin typeface="Segoe UI" pitchFamily="34" charset="0"/>
+                <a:ea typeface="Segoe UI" pitchFamily="34" charset="-122"/>
+                <a:cs typeface="Segoe UI" pitchFamily="34" charset="-120"/>
+              </a:rPr>
+              <a:t>6  </a:t>
+            </a:r>
+            <a:r>
               <a:rPr lang="en-US" sz="2300" dirty="0">
                 <a:solidFill>
                   <a:srgbClr val="2A2A33"/>
@@ -6432,85 +6242,45 @@
                 <a:ea typeface="Segoe UI" pitchFamily="34" charset="-122"/>
                 <a:cs typeface="Segoe UI" pitchFamily="34" charset="-120"/>
               </a:rPr>
-              <a:t>Forward error correction</a:t>
+              <a:t>Real-time audio</a:t>
             </a:r>
             <a:endParaRPr lang="en-US" sz="2300" dirty="0"/>
           </a:p>
           <a:p>
-            <a:pPr indent="0" marL="0">
+            <a:pPr marL="0" indent="0">
               <a:buNone/>
             </a:pPr>
             <a:r>
               <a:rPr lang="en-US" sz="2300" b="1" dirty="0">
                 <a:solidFill>
-                  <a:srgbClr val="F59E0B"/>
-                </a:solidFill>
-                <a:latin typeface="Segoe UI" pitchFamily="34" charset="0"/>
-                <a:ea typeface="Segoe UI" pitchFamily="34" charset="-122"/>
-                <a:cs typeface="Segoe UI" pitchFamily="34" charset="-120"/>
-              </a:rPr>
-              <a:t>6  </a:t>
-            </a:r>
-            <a:pPr indent="0" marL="0">
-              <a:spcAft>
-                <a:spcPts val="1800"/>
-              </a:spcAft>
+                  <a:srgbClr val="7C3AED"/>
+                </a:solidFill>
+                <a:latin typeface="Segoe UI" pitchFamily="34" charset="0"/>
+                <a:ea typeface="Segoe UI" pitchFamily="34" charset="-122"/>
+                <a:cs typeface="Segoe UI" pitchFamily="34" charset="-120"/>
+              </a:rPr>
+              <a:t>7  </a:t>
+            </a:r>
+            <a:r>
+              <a:rPr lang="en-US" sz="2300" dirty="0">
+                <a:solidFill>
+                  <a:srgbClr val="2A2A33"/>
+                </a:solidFill>
+                <a:latin typeface="Segoe UI" pitchFamily="34" charset="0"/>
+                <a:ea typeface="Segoe UI" pitchFamily="34" charset="-122"/>
+                <a:cs typeface="Segoe UI" pitchFamily="34" charset="-120"/>
+              </a:rPr>
+              <a:t>Security &amp; applications</a:t>
+            </a:r>
+            <a:endParaRPr lang="en-US" sz="2300" dirty="0"/>
+          </a:p>
+          <a:p>
+            <a:pPr marL="0" indent="0">
               <a:buNone/>
             </a:pPr>
             <a:r>
-              <a:rPr lang="en-US" sz="2300" dirty="0">
-                <a:solidFill>
-                  <a:srgbClr val="2A2A33"/>
-                </a:solidFill>
-                <a:latin typeface="Segoe UI" pitchFamily="34" charset="0"/>
-                <a:ea typeface="Segoe UI" pitchFamily="34" charset="-122"/>
-                <a:cs typeface="Segoe UI" pitchFamily="34" charset="-120"/>
-              </a:rPr>
-              <a:t>Real-time audio</a:t>
-            </a:r>
-            <a:endParaRPr lang="en-US" sz="2300" dirty="0"/>
-          </a:p>
-          <a:p>
-            <a:pPr indent="0" marL="0">
-              <a:buNone/>
-            </a:pPr>
-            <a:r>
               <a:rPr lang="en-US" sz="2300" b="1" dirty="0">
                 <a:solidFill>
-                  <a:srgbClr val="7C3AED"/>
-                </a:solidFill>
-                <a:latin typeface="Segoe UI" pitchFamily="34" charset="0"/>
-                <a:ea typeface="Segoe UI" pitchFamily="34" charset="-122"/>
-                <a:cs typeface="Segoe UI" pitchFamily="34" charset="-120"/>
-              </a:rPr>
-              <a:t>7  </a:t>
-            </a:r>
-            <a:pPr indent="0" marL="0">
-              <a:spcAft>
-                <a:spcPts val="1800"/>
-              </a:spcAft>
-              <a:buNone/>
-            </a:pPr>
-            <a:r>
-              <a:rPr lang="en-US" sz="2300" dirty="0">
-                <a:solidFill>
-                  <a:srgbClr val="2A2A33"/>
-                </a:solidFill>
-                <a:latin typeface="Segoe UI" pitchFamily="34" charset="0"/>
-                <a:ea typeface="Segoe UI" pitchFamily="34" charset="-122"/>
-                <a:cs typeface="Segoe UI" pitchFamily="34" charset="-120"/>
-              </a:rPr>
-              <a:t>Security &amp; applications</a:t>
-            </a:r>
-            <a:endParaRPr lang="en-US" sz="2300" dirty="0"/>
-          </a:p>
-          <a:p>
-            <a:pPr indent="0" marL="0">
-              <a:buNone/>
-            </a:pPr>
-            <a:r>
-              <a:rPr lang="en-US" sz="2300" b="1" dirty="0">
-                <a:solidFill>
                   <a:srgbClr val="06B6D4"/>
                 </a:solidFill>
                 <a:latin typeface="Segoe UI" pitchFamily="34" charset="0"/>
@@ -6519,12 +6289,6 @@
               </a:rPr>
               <a:t>8  </a:t>
             </a:r>
-            <a:pPr indent="0" marL="0">
-              <a:spcAft>
-                <a:spcPts val="1800"/>
-              </a:spcAft>
-              <a:buNone/>
-            </a:pPr>
             <a:r>
               <a:rPr lang="en-US" sz="2300" dirty="0">
                 <a:solidFill>
@@ -6581,7 +6345,7 @@
           <a:bodyPr wrap="square" rtlCol="0" anchor="ctr"/>
           <a:lstStyle/>
           <a:p>
-            <a:pPr algn="ctr" indent="0" marL="0">
+            <a:pPr marL="0" indent="0" algn="ctr">
               <a:buNone/>
             </a:pPr>
             <a:r>
@@ -6620,7 +6384,7 @@
           <a:bodyPr wrap="square" rtlCol="0" anchor="ctr"/>
           <a:lstStyle/>
           <a:p>
-            <a:pPr indent="0" marL="0">
+            <a:pPr marL="0" indent="0">
               <a:buNone/>
             </a:pPr>
             <a:r>
@@ -6654,6 +6418,7 @@
         <a:solidFill>
           <a:srgbClr val="FFFFFF"/>
         </a:solidFill>
+        <a:effectLst/>
       </p:bgPr>
     </p:bg>
     <p:spTree>
@@ -6751,7 +6516,7 @@
           <a:bodyPr wrap="square" rtlCol="0" anchor="ctr"/>
           <a:lstStyle/>
           <a:p>
-            <a:pPr indent="0" marL="0">
+            <a:pPr marL="0" indent="0">
               <a:buNone/>
             </a:pPr>
             <a:r>
@@ -6916,7 +6681,7 @@
           <a:bodyPr wrap="square" rtlCol="0" anchor="ctr"/>
           <a:lstStyle/>
           <a:p>
-            <a:pPr algn="ctr" indent="0" marL="0">
+            <a:pPr marL="0" indent="0" algn="ctr">
               <a:buNone/>
             </a:pPr>
             <a:r>
@@ -6955,7 +6720,7 @@
           <a:bodyPr wrap="square" rtlCol="0" anchor="ctr"/>
           <a:lstStyle/>
           <a:p>
-            <a:pPr indent="0" marL="0">
+            <a:pPr marL="0" indent="0">
               <a:buNone/>
             </a:pPr>
             <a:r>
@@ -6989,6 +6754,7 @@
         <a:solidFill>
           <a:srgbClr val="FFFFFF"/>
         </a:solidFill>
+        <a:effectLst/>
       </p:bgPr>
     </p:bg>
     <p:spTree>
@@ -7086,7 +6852,7 @@
           <a:bodyPr wrap="square" rtlCol="0" anchor="ctr"/>
           <a:lstStyle/>
           <a:p>
-            <a:pPr indent="0" marL="0">
+            <a:pPr marL="0" indent="0">
               <a:buNone/>
             </a:pPr>
             <a:r>
@@ -7218,8 +6984,8 @@
         </p:nvSpPr>
         <p:spPr>
           <a:xfrm>
-            <a:off x="1463040" y="3611880"/>
-            <a:ext cx="9235440" cy="2606040"/>
+            <a:off x="2243016" y="4126140"/>
+            <a:ext cx="7674707" cy="1641614"/>
           </a:xfrm>
           <a:prstGeom prst="roundRect">
             <a:avLst>
@@ -7239,21 +7005,21 @@
       </p:sp>
       <p:pic>
         <p:nvPicPr>
-          <p:cNvPr id="8" name="Image 0" descr="C:/Users/h/AppData/Local/Temp/claude/c--Users-h-Desktop-Mini-project-Fec-Mini-Project/4af49bb4-fc29-49ed-b315-f05a2bedcaee/scratchpad/pptxbuild/assets/context.png">    </p:cNvPr>
+          <p:cNvPr id="8" name="Image 0" descr="C:/Users/h/AppData/Local/Temp/claude/c--Users-h-Desktop-Mini-project-Fec-Mini-Project/4af49bb4-fc29-49ed-b315-f05a2bedcaee/scratchpad/pptxbuild/assets/context.png"/>
           <p:cNvPicPr>
             <a:picLocks noChangeAspect="1"/>
           </p:cNvPicPr>
           <p:nvPr/>
         </p:nvPicPr>
         <p:blipFill>
-          <a:blip r:embed="rId1"/>
-          <a:srcRect l="0" r="0" t="0" b="0"/>
+          <a:blip r:embed="rId3"/>
+          <a:srcRect/>
           <a:stretch/>
         </p:blipFill>
         <p:spPr>
           <a:xfrm>
-            <a:off x="1609344" y="3758184"/>
-            <a:ext cx="8942832" cy="2313432"/>
+            <a:off x="2449267" y="4244873"/>
+            <a:ext cx="7293160" cy="1388517"/>
           </a:xfrm>
           <a:prstGeom prst="rect">
             <a:avLst/>
@@ -7301,7 +7067,7 @@
           <a:bodyPr wrap="square" rtlCol="0" anchor="ctr"/>
           <a:lstStyle/>
           <a:p>
-            <a:pPr algn="ctr" indent="0" marL="0">
+            <a:pPr marL="0" indent="0" algn="ctr">
               <a:buNone/>
             </a:pPr>
             <a:r>
@@ -7340,7 +7106,7 @@
           <a:bodyPr wrap="square" rtlCol="0" anchor="ctr"/>
           <a:lstStyle/>
           <a:p>
-            <a:pPr indent="0" marL="0">
+            <a:pPr marL="0" indent="0">
               <a:buNone/>
             </a:pPr>
             <a:r>
@@ -7374,6 +7140,7 @@
         <a:solidFill>
           <a:srgbClr val="FFFFFF"/>
         </a:solidFill>
+        <a:effectLst/>
       </p:bgPr>
     </p:bg>
     <p:spTree>
@@ -7471,7 +7238,7 @@
           <a:bodyPr wrap="square" rtlCol="0" anchor="ctr"/>
           <a:lstStyle/>
           <a:p>
-            <a:pPr indent="0" marL="0">
+            <a:pPr marL="0" indent="0">
               <a:buNone/>
             </a:pPr>
             <a:r>
@@ -7624,15 +7391,15 @@
       </p:sp>
       <p:pic>
         <p:nvPicPr>
-          <p:cNvPr id="8" name="Image 0" descr="C:/Users/h/AppData/Local/Temp/claude/c--Users-h-Desktop-Mini-project-Fec-Mini-Project/4af49bb4-fc29-49ed-b315-f05a2bedcaee/scratchpad/pptxbuild/assets/architecture.png">    </p:cNvPr>
+          <p:cNvPr id="8" name="Image 0" descr="C:/Users/h/AppData/Local/Temp/claude/c--Users-h-Desktop-Mini-project-Fec-Mini-Project/4af49bb4-fc29-49ed-b315-f05a2bedcaee/scratchpad/pptxbuild/assets/architecture.png"/>
           <p:cNvPicPr>
             <a:picLocks noChangeAspect="1"/>
           </p:cNvPicPr>
           <p:nvPr/>
         </p:nvPicPr>
         <p:blipFill>
-          <a:blip r:embed="rId1"/>
-          <a:srcRect l="0" r="0" t="0" b="0"/>
+          <a:blip r:embed="rId3"/>
+          <a:srcRect/>
           <a:stretch/>
         </p:blipFill>
         <p:spPr>
@@ -7686,7 +7453,7 @@
           <a:bodyPr wrap="square" rtlCol="0" anchor="ctr"/>
           <a:lstStyle/>
           <a:p>
-            <a:pPr algn="ctr" indent="0" marL="0">
+            <a:pPr marL="0" indent="0" algn="ctr">
               <a:buNone/>
             </a:pPr>
             <a:r>
@@ -7725,7 +7492,7 @@
           <a:bodyPr wrap="square" rtlCol="0" anchor="ctr"/>
           <a:lstStyle/>
           <a:p>
-            <a:pPr indent="0" marL="0">
+            <a:pPr marL="0" indent="0">
               <a:buNone/>
             </a:pPr>
             <a:r>
@@ -7759,6 +7526,7 @@
         <a:solidFill>
           <a:srgbClr val="FFFFFF"/>
         </a:solidFill>
+        <a:effectLst/>
       </p:bgPr>
     </p:bg>
     <p:spTree>
@@ -7856,7 +7624,7 @@
           <a:bodyPr wrap="square" rtlCol="0" anchor="ctr"/>
           <a:lstStyle/>
           <a:p>
-            <a:pPr indent="0" marL="0">
+            <a:pPr marL="0" indent="0">
               <a:buNone/>
             </a:pPr>
             <a:r>
@@ -8049,7 +7817,7 @@
           <a:bodyPr wrap="square" rtlCol="0" anchor="t"/>
           <a:lstStyle/>
           <a:p>
-            <a:pPr indent="0" marL="0">
+            <a:pPr marL="0" indent="0">
               <a:lnSpc>
                 <a:spcPct val="125000"/>
               </a:lnSpc>
@@ -8071,7 +7839,7 @@
             <a:endParaRPr lang="en-US" sz="1400" dirty="0"/>
           </a:p>
           <a:p>
-            <a:pPr indent="0" marL="0">
+            <a:pPr marL="0" indent="0">
               <a:lnSpc>
                 <a:spcPct val="125000"/>
               </a:lnSpc>
@@ -8092,7 +7860,7 @@
             <a:endParaRPr lang="en-US" sz="1400" dirty="0"/>
           </a:p>
           <a:p>
-            <a:pPr indent="0" marL="0">
+            <a:pPr marL="0" indent="0">
               <a:lnSpc>
                 <a:spcPct val="125000"/>
               </a:lnSpc>
@@ -8154,7 +7922,7 @@
           <a:bodyPr wrap="square" rtlCol="0" anchor="ctr"/>
           <a:lstStyle/>
           <a:p>
-            <a:pPr algn="ctr" indent="0" marL="0">
+            <a:pPr marL="0" indent="0" algn="ctr">
               <a:buNone/>
             </a:pPr>
             <a:r>
@@ -8193,7 +7961,7 @@
           <a:bodyPr wrap="square" rtlCol="0" anchor="ctr"/>
           <a:lstStyle/>
           <a:p>
-            <a:pPr indent="0" marL="0">
+            <a:pPr marL="0" indent="0">
               <a:buNone/>
             </a:pPr>
             <a:r>
@@ -8227,6 +7995,7 @@
         <a:solidFill>
           <a:srgbClr val="FFFFFF"/>
         </a:solidFill>
+        <a:effectLst/>
       </p:bgPr>
     </p:bg>
     <p:spTree>
@@ -8324,7 +8093,7 @@
           <a:bodyPr wrap="square" rtlCol="0" anchor="ctr"/>
           <a:lstStyle/>
           <a:p>
-            <a:pPr indent="0" marL="0">
+            <a:pPr marL="0" indent="0">
               <a:buNone/>
             </a:pPr>
             <a:r>
@@ -8473,7 +8242,7 @@
           <a:bodyPr wrap="square" rtlCol="0" anchor="ctr"/>
           <a:lstStyle/>
           <a:p>
-            <a:pPr algn="ctr" indent="0" marL="0">
+            <a:pPr marL="0" indent="0" algn="ctr">
               <a:buNone/>
             </a:pPr>
             <a:r>
@@ -8490,7 +8259,7 @@
             <a:endParaRPr lang="en-US" sz="1500" dirty="0"/>
           </a:p>
           <a:p>
-            <a:pPr algn="ctr" indent="0" marL="0">
+            <a:pPr marL="0" indent="0" algn="ctr">
               <a:buNone/>
             </a:pPr>
             <a:r>
@@ -8554,7 +8323,7 @@
           <a:bodyPr wrap="square" rtlCol="0" anchor="ctr"/>
           <a:lstStyle/>
           <a:p>
-            <a:pPr algn="ctr" indent="0" marL="0">
+            <a:pPr marL="0" indent="0" algn="ctr">
               <a:buNone/>
             </a:pPr>
             <a:r>
@@ -8571,7 +8340,7 @@
             <a:endParaRPr lang="en-US" sz="1500" dirty="0"/>
           </a:p>
           <a:p>
-            <a:pPr algn="ctr" indent="0" marL="0">
+            <a:pPr marL="0" indent="0" algn="ctr">
               <a:buNone/>
             </a:pPr>
             <a:r>
@@ -8635,7 +8404,7 @@
           <a:bodyPr wrap="square" rtlCol="0" anchor="ctr"/>
           <a:lstStyle/>
           <a:p>
-            <a:pPr algn="ctr" indent="0" marL="0">
+            <a:pPr marL="0" indent="0" algn="ctr">
               <a:buNone/>
             </a:pPr>
             <a:r>
@@ -8652,7 +8421,7 @@
             <a:endParaRPr lang="en-US" sz="1500" dirty="0"/>
           </a:p>
           <a:p>
-            <a:pPr algn="ctr" indent="0" marL="0">
+            <a:pPr marL="0" indent="0" algn="ctr">
               <a:buNone/>
             </a:pPr>
             <a:r>
@@ -8716,7 +8485,7 @@
           <a:bodyPr wrap="square" rtlCol="0" anchor="ctr"/>
           <a:lstStyle/>
           <a:p>
-            <a:pPr algn="ctr" indent="0" marL="0">
+            <a:pPr marL="0" indent="0" algn="ctr">
               <a:buNone/>
             </a:pPr>
             <a:r>
@@ -8733,7 +8502,7 @@
             <a:endParaRPr lang="en-US" sz="1500" dirty="0"/>
           </a:p>
           <a:p>
-            <a:pPr algn="ctr" indent="0" marL="0">
+            <a:pPr marL="0" indent="0" algn="ctr">
               <a:buNone/>
             </a:pPr>
             <a:r>
@@ -8797,7 +8566,7 @@
           <a:bodyPr wrap="square" rtlCol="0" anchor="ctr"/>
           <a:lstStyle/>
           <a:p>
-            <a:pPr algn="ctr" indent="0" marL="0">
+            <a:pPr marL="0" indent="0" algn="ctr">
               <a:buNone/>
             </a:pPr>
             <a:r>
@@ -8814,7 +8583,7 @@
             <a:endParaRPr lang="en-US" sz="1300" dirty="0"/>
           </a:p>
           <a:p>
-            <a:pPr algn="ctr" indent="0" marL="0">
+            <a:pPr marL="0" indent="0" algn="ctr">
               <a:buNone/>
             </a:pPr>
             <a:r>
@@ -8878,7 +8647,7 @@
           <a:bodyPr wrap="square" rtlCol="0" anchor="ctr"/>
           <a:lstStyle/>
           <a:p>
-            <a:pPr algn="ctr" indent="0" marL="0">
+            <a:pPr marL="0" indent="0" algn="ctr">
               <a:buNone/>
             </a:pPr>
             <a:r>
@@ -8895,7 +8664,7 @@
             <a:endParaRPr lang="en-US" sz="1300" dirty="0"/>
           </a:p>
           <a:p>
-            <a:pPr algn="ctr" indent="0" marL="0">
+            <a:pPr marL="0" indent="0" algn="ctr">
               <a:buNone/>
             </a:pPr>
             <a:r>
@@ -8934,7 +8703,7 @@
           <a:bodyPr wrap="square" rtlCol="0" anchor="ctr"/>
           <a:lstStyle/>
           <a:p>
-            <a:pPr indent="0" marL="0">
+            <a:pPr marL="0" indent="0">
               <a:buNone/>
             </a:pPr>
             <a:r>
@@ -8993,7 +8762,7 @@
           <a:bodyPr wrap="square" rtlCol="0" anchor="ctr"/>
           <a:lstStyle/>
           <a:p>
-            <a:pPr algn="ctr" indent="0" marL="0">
+            <a:pPr marL="0" indent="0" algn="ctr">
               <a:buNone/>
             </a:pPr>
             <a:r>
@@ -9032,7 +8801,7 @@
           <a:bodyPr wrap="square" rtlCol="0" anchor="ctr"/>
           <a:lstStyle/>
           <a:p>
-            <a:pPr indent="0" marL="0">
+            <a:pPr marL="0" indent="0">
               <a:buNone/>
             </a:pPr>
             <a:r>
@@ -9066,6 +8835,7 @@
         <a:solidFill>
           <a:srgbClr val="FFFFFF"/>
         </a:solidFill>
+        <a:effectLst/>
       </p:bgPr>
     </p:bg>
     <p:spTree>
@@ -9163,7 +8933,7 @@
           <a:bodyPr wrap="square" rtlCol="0" anchor="ctr"/>
           <a:lstStyle/>
           <a:p>
-            <a:pPr indent="0" marL="0">
+            <a:pPr marL="0" indent="0">
               <a:buNone/>
             </a:pPr>
             <a:r>
@@ -9295,8 +9065,8 @@
         </p:nvSpPr>
         <p:spPr>
           <a:xfrm>
-            <a:off x="1737360" y="3611880"/>
-            <a:ext cx="8686800" cy="2606040"/>
+            <a:off x="1774092" y="3469953"/>
+            <a:ext cx="8650067" cy="2967423"/>
           </a:xfrm>
           <a:prstGeom prst="roundRect">
             <a:avLst>
@@ -9316,21 +9086,21 @@
       </p:sp>
       <p:pic>
         <p:nvPicPr>
-          <p:cNvPr id="8" name="Image 0" descr="C:/Users/h/AppData/Local/Temp/claude/c--Users-h-Desktop-Mini-project-Fec-Mini-Project/4af49bb4-fc29-49ed-b315-f05a2bedcaee/scratchpad/pptxbuild/assets/xor-fec.png">    </p:cNvPr>
+          <p:cNvPr id="8" name="Image 0" descr="C:/Users/h/AppData/Local/Temp/claude/c--Users-h-Desktop-Mini-project-Fec-Mini-Project/4af49bb4-fc29-49ed-b315-f05a2bedcaee/scratchpad/pptxbuild/assets/xor-fec.png"/>
           <p:cNvPicPr>
             <a:picLocks noChangeAspect="1"/>
           </p:cNvPicPr>
           <p:nvPr/>
         </p:nvPicPr>
         <p:blipFill>
-          <a:blip r:embed="rId1"/>
-          <a:srcRect l="0" r="0" t="0" b="0"/>
+          <a:blip r:embed="rId3"/>
+          <a:srcRect/>
           <a:stretch/>
         </p:blipFill>
         <p:spPr>
           <a:xfrm>
-            <a:off x="1883664" y="3758184"/>
-            <a:ext cx="8394192" cy="2313432"/>
+            <a:off x="2942312" y="3611880"/>
+            <a:ext cx="6276895" cy="2683569"/>
           </a:xfrm>
           <a:prstGeom prst="rect">
             <a:avLst/>
@@ -9378,7 +9148,7 @@
           <a:bodyPr wrap="square" rtlCol="0" anchor="ctr"/>
           <a:lstStyle/>
           <a:p>
-            <a:pPr algn="ctr" indent="0" marL="0">
+            <a:pPr marL="0" indent="0" algn="ctr">
               <a:buNone/>
             </a:pPr>
             <a:r>
@@ -9417,7 +9187,7 @@
           <a:bodyPr wrap="square" rtlCol="0" anchor="ctr"/>
           <a:lstStyle/>
           <a:p>
-            <a:pPr indent="0" marL="0">
+            <a:pPr marL="0" indent="0">
               <a:buNone/>
             </a:pPr>
             <a:r>
@@ -9451,6 +9221,7 @@
         <a:solidFill>
           <a:srgbClr val="FFFFFF"/>
         </a:solidFill>
+        <a:effectLst/>
       </p:bgPr>
     </p:bg>
     <p:spTree>
@@ -9548,7 +9319,7 @@
           <a:bodyPr wrap="square" rtlCol="0" anchor="ctr"/>
           <a:lstStyle/>
           <a:p>
-            <a:pPr indent="0" marL="0">
+            <a:pPr marL="0" indent="0">
               <a:buNone/>
             </a:pPr>
             <a:r>
@@ -9720,7 +9491,7 @@
           <a:bodyPr wrap="square" rtlCol="0" anchor="ctr"/>
           <a:lstStyle/>
           <a:p>
-            <a:pPr algn="ctr" indent="0" marL="0">
+            <a:pPr marL="0" indent="0" algn="ctr">
               <a:buNone/>
             </a:pPr>
             <a:r>
@@ -9740,15 +9511,15 @@
       </p:sp>
       <p:pic>
         <p:nvPicPr>
-          <p:cNvPr id="9" name="Image 0" descr="C:/Users/h/AppData/Local/Temp/claude/c--Users-h-Desktop-Mini-project-Fec-Mini-Project/4af49bb4-fc29-49ed-b315-f05a2bedcaee/scratchpad/pptxbuild/assets/audio-pipe-transmit.png">    </p:cNvPr>
+          <p:cNvPr id="9" name="Image 0" descr="C:/Users/h/AppData/Local/Temp/claude/c--Users-h-Desktop-Mini-project-Fec-Mini-Project/4af49bb4-fc29-49ed-b315-f05a2bedcaee/scratchpad/pptxbuild/assets/audio-pipe-transmit.png"/>
           <p:cNvPicPr>
             <a:picLocks noChangeAspect="1"/>
           </p:cNvPicPr>
           <p:nvPr/>
         </p:nvPicPr>
         <p:blipFill>
-          <a:blip r:embed="rId1"/>
-          <a:srcRect l="0" r="0" t="0" b="0"/>
+          <a:blip r:embed="rId3"/>
+          <a:srcRect/>
           <a:stretch/>
         </p:blipFill>
         <p:spPr>
@@ -9809,7 +9580,7 @@
           <a:bodyPr wrap="square" rtlCol="0" anchor="ctr"/>
           <a:lstStyle/>
           <a:p>
-            <a:pPr algn="ctr" indent="0" marL="0">
+            <a:pPr marL="0" indent="0" algn="ctr">
               <a:buNone/>
             </a:pPr>
             <a:r>
@@ -9829,15 +9600,15 @@
       </p:sp>
       <p:pic>
         <p:nvPicPr>
-          <p:cNvPr id="12" name="Image 1" descr="C:/Users/h/AppData/Local/Temp/claude/c--Users-h-Desktop-Mini-project-Fec-Mini-Project/4af49bb4-fc29-49ed-b315-f05a2bedcaee/scratchpad/pptxbuild/assets/audio-pipe-receive.png">    </p:cNvPr>
+          <p:cNvPr id="12" name="Image 1" descr="C:/Users/h/AppData/Local/Temp/claude/c--Users-h-Desktop-Mini-project-Fec-Mini-Project/4af49bb4-fc29-49ed-b315-f05a2bedcaee/scratchpad/pptxbuild/assets/audio-pipe-receive.png"/>
           <p:cNvPicPr>
             <a:picLocks noChangeAspect="1"/>
           </p:cNvPicPr>
           <p:nvPr/>
         </p:nvPicPr>
         <p:blipFill>
-          <a:blip r:embed="rId2"/>
-          <a:srcRect l="0" r="0" t="0" b="0"/>
+          <a:blip r:embed="rId4"/>
+          <a:srcRect/>
           <a:stretch/>
         </p:blipFill>
         <p:spPr>
@@ -9891,7 +9662,7 @@
           <a:bodyPr wrap="square" rtlCol="0" anchor="ctr"/>
           <a:lstStyle/>
           <a:p>
-            <a:pPr algn="ctr" indent="0" marL="0">
+            <a:pPr marL="0" indent="0" algn="ctr">
               <a:buNone/>
             </a:pPr>
             <a:r>
@@ -9930,7 +9701,7 @@
           <a:bodyPr wrap="square" rtlCol="0" anchor="ctr"/>
           <a:lstStyle/>
           <a:p>
-            <a:pPr indent="0" marL="0">
+            <a:pPr marL="0" indent="0">
               <a:buNone/>
             </a:pPr>
             <a:r>
@@ -10249,4 +10020,265 @@
     </a:ext>
   </a:extLst>
 </a:theme>
+</file>
+
+<file path=ppt/theme/theme2.xml><?xml version="1.0" encoding="utf-8"?>
+<a:theme xmlns:a="http://schemas.openxmlformats.org/drawingml/2006/main" name="Office Theme">
+  <a:themeElements>
+    <a:clrScheme name="Office">
+      <a:dk1>
+        <a:sysClr val="windowText" lastClr="000000"/>
+      </a:dk1>
+      <a:lt1>
+        <a:sysClr val="window" lastClr="FFFFFF"/>
+      </a:lt1>
+      <a:dk2>
+        <a:srgbClr val="44546A"/>
+      </a:dk2>
+      <a:lt2>
+        <a:srgbClr val="E7E6E6"/>
+      </a:lt2>
+      <a:accent1>
+        <a:srgbClr val="5B9BD5"/>
+      </a:accent1>
+      <a:accent2>
+        <a:srgbClr val="ED7D31"/>
+      </a:accent2>
+      <a:accent3>
+        <a:srgbClr val="A5A5A5"/>
+      </a:accent3>
+      <a:accent4>
+        <a:srgbClr val="FFC000"/>
+      </a:accent4>
+      <a:accent5>
+        <a:srgbClr val="4472C4"/>
+      </a:accent5>
+      <a:accent6>
+        <a:srgbClr val="70AD47"/>
+      </a:accent6>
+      <a:hlink>
+        <a:srgbClr val="0563C1"/>
+      </a:hlink>
+      <a:folHlink>
+        <a:srgbClr val="954F72"/>
+      </a:folHlink>
+    </a:clrScheme>
+    <a:fontScheme name="Office">
+      <a:majorFont>
+        <a:latin typeface="Calibri Light" panose="020F0302020204030204"/>
+        <a:ea typeface=""/>
+        <a:cs typeface=""/>
+        <a:font script="Jpan" typeface="游ゴシック Light"/>
+        <a:font script="Hang" typeface="맑은 고딕"/>
+        <a:font script="Hans" typeface="等线 Light"/>
+        <a:font script="Hant" typeface="新細明體"/>
+        <a:font script="Arab" typeface="Times New Roman"/>
+        <a:font script="Hebr" typeface="Times New Roman"/>
+        <a:font script="Thai" typeface="Angsana New"/>
+        <a:font script="Ethi" typeface="Nyala"/>
+        <a:font script="Beng" typeface="Vrinda"/>
+        <a:font script="Gujr" typeface="Shruti"/>
+        <a:font script="Khmr" typeface="MoolBoran"/>
+        <a:font script="Knda" typeface="Tunga"/>
+        <a:font script="Guru" typeface="Raavi"/>
+        <a:font script="Cans" typeface="Euphemia"/>
+        <a:font script="Cher" typeface="Plantagenet Cherokee"/>
+        <a:font script="Yiii" typeface="Microsoft Yi Baiti"/>
+        <a:font script="Tibt" typeface="Microsoft Himalaya"/>
+        <a:font script="Thaa" typeface="MV Boli"/>
+        <a:font script="Deva" typeface="Mangal"/>
+        <a:font script="Telu" typeface="Gautami"/>
+        <a:font script="Taml" typeface="Latha"/>
+        <a:font script="Syrc" typeface="Estrangelo Edessa"/>
+        <a:font script="Orya" typeface="Kalinga"/>
+        <a:font script="Mlym" typeface="Kartika"/>
+        <a:font script="Laoo" typeface="DokChampa"/>
+        <a:font script="Sinh" typeface="Iskoola Pota"/>
+        <a:font script="Mong" typeface="Mongolian Baiti"/>
+        <a:font script="Viet" typeface="Times New Roman"/>
+        <a:font script="Uigh" typeface="Microsoft Uighur"/>
+        <a:font script="Geor" typeface="Sylfaen"/>
+      </a:majorFont>
+      <a:minorFont>
+        <a:latin typeface="Calibri" panose="020F0502020204030204"/>
+        <a:ea typeface=""/>
+        <a:cs typeface=""/>
+        <a:font script="Jpan" typeface="游ゴシック"/>
+        <a:font script="Hang" typeface="맑은 고딕"/>
+        <a:font script="Hans" typeface="等线"/>
+        <a:font script="Hant" typeface="新細明體"/>
+        <a:font script="Arab" typeface="Arial"/>
+        <a:font script="Hebr" typeface="Arial"/>
+        <a:font script="Thai" typeface="Cordia New"/>
+        <a:font script="Ethi" typeface="Nyala"/>
+        <a:font script="Beng" typeface="Vrinda"/>
+        <a:font script="Gujr" typeface="Shruti"/>
+        <a:font script="Khmr" typeface="DaunPenh"/>
+        <a:font script="Knda" typeface="Tunga"/>
+        <a:font script="Guru" typeface="Raavi"/>
+        <a:font script="Cans" typeface="Euphemia"/>
+        <a:font script="Cher" typeface="Plantagenet Cherokee"/>
+        <a:font script="Yiii" typeface="Microsoft Yi Baiti"/>
+        <a:font script="Tibt" typeface="Microsoft Himalaya"/>
+        <a:font script="Thaa" typeface="MV Boli"/>
+        <a:font script="Deva" typeface="Mangal"/>
+        <a:font script="Telu" typeface="Gautami"/>
+        <a:font script="Taml" typeface="Latha"/>
+        <a:font script="Syrc" typeface="Estrangelo Edessa"/>
+        <a:font script="Orya" typeface="Kalinga"/>
+        <a:font script="Mlym" typeface="Kartika"/>
+        <a:font script="Laoo" typeface="DokChampa"/>
+        <a:font script="Sinh" typeface="Iskoola Pota"/>
+        <a:font script="Mong" typeface="Mongolian Baiti"/>
+        <a:font script="Viet" typeface="Arial"/>
+        <a:font script="Uigh" typeface="Microsoft Uighur"/>
+        <a:font script="Geor" typeface="Sylfaen"/>
+      </a:minorFont>
+    </a:fontScheme>
+    <a:fmtScheme name="Office">
+      <a:fillStyleLst>
+        <a:solidFill>
+          <a:schemeClr val="phClr"/>
+        </a:solidFill>
+        <a:gradFill rotWithShape="1">
+          <a:gsLst>
+            <a:gs pos="0">
+              <a:schemeClr val="phClr">
+                <a:lumMod val="110000"/>
+                <a:satMod val="105000"/>
+                <a:tint val="67000"/>
+              </a:schemeClr>
+            </a:gs>
+            <a:gs pos="50000">
+              <a:schemeClr val="phClr">
+                <a:lumMod val="105000"/>
+                <a:satMod val="103000"/>
+                <a:tint val="73000"/>
+              </a:schemeClr>
+            </a:gs>
+            <a:gs pos="100000">
+              <a:schemeClr val="phClr">
+                <a:lumMod val="105000"/>
+                <a:satMod val="109000"/>
+                <a:tint val="81000"/>
+              </a:schemeClr>
+            </a:gs>
+          </a:gsLst>
+          <a:lin ang="5400000" scaled="0"/>
+        </a:gradFill>
+        <a:gradFill rotWithShape="1">
+          <a:gsLst>
+            <a:gs pos="0">
+              <a:schemeClr val="phClr">
+                <a:satMod val="103000"/>
+                <a:lumMod val="102000"/>
+                <a:tint val="94000"/>
+              </a:schemeClr>
+            </a:gs>
+            <a:gs pos="50000">
+              <a:schemeClr val="phClr">
+                <a:satMod val="110000"/>
+                <a:lumMod val="100000"/>
+                <a:shade val="100000"/>
+              </a:schemeClr>
+            </a:gs>
+            <a:gs pos="100000">
+              <a:schemeClr val="phClr">
+                <a:lumMod val="99000"/>
+                <a:satMod val="120000"/>
+                <a:shade val="78000"/>
+              </a:schemeClr>
+            </a:gs>
+          </a:gsLst>
+          <a:lin ang="5400000" scaled="0"/>
+        </a:gradFill>
+      </a:fillStyleLst>
+      <a:lnStyleLst>
+        <a:ln w="6350" cap="flat" cmpd="sng" algn="ctr">
+          <a:solidFill>
+            <a:schemeClr val="phClr"/>
+          </a:solidFill>
+          <a:prstDash val="solid"/>
+          <a:miter lim="800000"/>
+        </a:ln>
+        <a:ln w="12700" cap="flat" cmpd="sng" algn="ctr">
+          <a:solidFill>
+            <a:schemeClr val="phClr"/>
+          </a:solidFill>
+          <a:prstDash val="solid"/>
+          <a:miter lim="800000"/>
+        </a:ln>
+        <a:ln w="19050" cap="flat" cmpd="sng" algn="ctr">
+          <a:solidFill>
+            <a:schemeClr val="phClr"/>
+          </a:solidFill>
+          <a:prstDash val="solid"/>
+          <a:miter lim="800000"/>
+        </a:ln>
+      </a:lnStyleLst>
+      <a:effectStyleLst>
+        <a:effectStyle>
+          <a:effectLst/>
+        </a:effectStyle>
+        <a:effectStyle>
+          <a:effectLst/>
+        </a:effectStyle>
+        <a:effectStyle>
+          <a:effectLst>
+            <a:outerShdw blurRad="57150" dist="19050" dir="5400000" algn="ctr" rotWithShape="0">
+              <a:srgbClr val="000000">
+                <a:alpha val="63000"/>
+              </a:srgbClr>
+            </a:outerShdw>
+          </a:effectLst>
+        </a:effectStyle>
+      </a:effectStyleLst>
+      <a:bgFillStyleLst>
+        <a:solidFill>
+          <a:schemeClr val="phClr"/>
+        </a:solidFill>
+        <a:solidFill>
+          <a:schemeClr val="phClr">
+            <a:tint val="95000"/>
+            <a:satMod val="170000"/>
+          </a:schemeClr>
+        </a:solidFill>
+        <a:gradFill rotWithShape="1">
+          <a:gsLst>
+            <a:gs pos="0">
+              <a:schemeClr val="phClr">
+                <a:tint val="93000"/>
+                <a:satMod val="150000"/>
+                <a:shade val="98000"/>
+                <a:lumMod val="102000"/>
+              </a:schemeClr>
+            </a:gs>
+            <a:gs pos="50000">
+              <a:schemeClr val="phClr">
+                <a:tint val="98000"/>
+                <a:satMod val="130000"/>
+                <a:shade val="90000"/>
+                <a:lumMod val="103000"/>
+              </a:schemeClr>
+            </a:gs>
+            <a:gs pos="100000">
+              <a:schemeClr val="phClr">
+                <a:shade val="63000"/>
+                <a:satMod val="120000"/>
+              </a:schemeClr>
+            </a:gs>
+          </a:gsLst>
+          <a:lin ang="5400000" scaled="0"/>
+        </a:gradFill>
+      </a:bgFillStyleLst>
+    </a:fmtScheme>
+  </a:themeElements>
+  <a:objectDefaults/>
+  <a:extraClrSchemeLst/>
+  <a:extLst>
+    <a:ext uri="{05A4C25C-085E-4340-85A3-A5531E510DB2}">
+      <thm15:themeFamily xmlns:thm15="http://schemas.microsoft.com/office/thememl/2012/main" name="Office Theme" id="{62F939B6-93AF-4DB8-9C6B-D6C7DFDC589F}" vid="{4A3C46E8-61CC-4603-A589-7422A47A8E4A}"/>
+    </a:ext>
+  </a:extLst>
+</a:theme>
 </file>
</xml_diff>